<commit_message>
Added little bit of details about weight decay and unbiasedness in Slides 3
Signed-off-by: JasonMendoza2008 <lhotteromain@gmail.com>
</commit_message>
<xml_diff>
--- a/Slides/Slides_3.pptx
+++ b/Slides/Slides_3.pptx
@@ -5,7 +5,7 @@
     <p:sldMasterId id="2147483648" r:id="rId1"/>
   </p:sldMasterIdLst>
   <p:notesMasterIdLst>
-    <p:notesMasterId r:id="rId27"/>
+    <p:notesMasterId r:id="rId28"/>
   </p:notesMasterIdLst>
   <p:sldIdLst>
     <p:sldId id="332" r:id="rId2"/>
@@ -17,22 +17,23 @@
     <p:sldId id="336" r:id="rId8"/>
     <p:sldId id="337" r:id="rId9"/>
     <p:sldId id="358" r:id="rId10"/>
-    <p:sldId id="345" r:id="rId11"/>
-    <p:sldId id="338" r:id="rId12"/>
-    <p:sldId id="346" r:id="rId13"/>
-    <p:sldId id="340" r:id="rId14"/>
-    <p:sldId id="341" r:id="rId15"/>
-    <p:sldId id="355" r:id="rId16"/>
-    <p:sldId id="342" r:id="rId17"/>
-    <p:sldId id="343" r:id="rId18"/>
-    <p:sldId id="344" r:id="rId19"/>
-    <p:sldId id="347" r:id="rId20"/>
-    <p:sldId id="349" r:id="rId21"/>
-    <p:sldId id="350" r:id="rId22"/>
-    <p:sldId id="351" r:id="rId23"/>
-    <p:sldId id="352" r:id="rId24"/>
-    <p:sldId id="353" r:id="rId25"/>
-    <p:sldId id="356" r:id="rId26"/>
+    <p:sldId id="359" r:id="rId11"/>
+    <p:sldId id="345" r:id="rId12"/>
+    <p:sldId id="338" r:id="rId13"/>
+    <p:sldId id="346" r:id="rId14"/>
+    <p:sldId id="340" r:id="rId15"/>
+    <p:sldId id="341" r:id="rId16"/>
+    <p:sldId id="355" r:id="rId17"/>
+    <p:sldId id="342" r:id="rId18"/>
+    <p:sldId id="343" r:id="rId19"/>
+    <p:sldId id="344" r:id="rId20"/>
+    <p:sldId id="347" r:id="rId21"/>
+    <p:sldId id="349" r:id="rId22"/>
+    <p:sldId id="350" r:id="rId23"/>
+    <p:sldId id="351" r:id="rId24"/>
+    <p:sldId id="352" r:id="rId25"/>
+    <p:sldId id="353" r:id="rId26"/>
+    <p:sldId id="356" r:id="rId27"/>
   </p:sldIdLst>
   <p:sldSz cx="12192000" cy="6858000"/>
   <p:notesSz cx="6858000" cy="9144000"/>
@@ -651,22 +652,23 @@
         <inkml:traceFormat>
           <inkml:channel name="X" type="integer" min="-2.14748E9" max="2.14748E9" units="cm"/>
           <inkml:channel name="Y" type="integer" min="-2.14748E9" max="2.14748E9" units="cm"/>
+          <inkml:channel name="F" type="integer" max="32767" units="dev"/>
         </inkml:traceFormat>
         <inkml:channelProperties>
           <inkml:channelProperty channel="X" name="resolution" value="1000" units="1/cm"/>
           <inkml:channelProperty channel="Y" name="resolution" value="1000" units="1/cm"/>
+          <inkml:channelProperty channel="F" name="resolution" value="0" units="1/dev"/>
         </inkml:channelProperties>
       </inkml:inkSource>
-      <inkml:timestamp xml:id="ts0" timeString="2023-01-17T15:32:29.124"/>
+      <inkml:timestamp xml:id="ts0" timeString="2026-01-09T19:01:44.153"/>
     </inkml:context>
     <inkml:brush xml:id="br0">
-      <inkml:brushProperty name="width" value="0.2" units="cm"/>
-      <inkml:brushProperty name="height" value="0.2" units="cm"/>
+      <inkml:brushProperty name="width" value="0.035" units="cm"/>
+      <inkml:brushProperty name="height" value="0.035" units="cm"/>
       <inkml:brushProperty name="color" value="#E71224"/>
-      <inkml:brushProperty name="ignorePressure" value="1"/>
     </inkml:brush>
   </inkml:definitions>
-  <inkml:trace contextRef="#ctx0" brushRef="#br0">0 0,'12824'0,"-12790"0</inkml:trace>
+  <inkml:trace contextRef="#ctx0" brushRef="#br0">1 2 24575,'22'0'0,"-12"-1"0,1 1 0,0 0 0,12 3 0,-20-2 0,1 0 0,0 0 0,-1 0 0,1 0 0,-1 1 0,1 0 0,-1-1 0,0 1 0,0 1 0,0-1 0,0 0 0,5 6 0,6 7 0,11 11 0,-1 1 0,25 37 0,-44-56 0,-1 0 0,0 1 0,-1-1 0,1 1 0,-2 0 0,1 0 0,-1 0 0,1 13 0,-1 7 0,-2 40 0,-1-23 0,0-34 0,-1-1 0,0 1 0,-1-1 0,0 1 0,-1-1 0,0 0 0,0-1 0,-1 1 0,-11 16 0,0 3 0,5-5 0,2 0 0,-10 42 0,13-46 0,4-16 0,1 0 0,0 0 0,0 0 0,0 0 0,1 0 0,0 0 0,0 0 0,0 0 0,2 10 0,-2-13 0,1 0 0,0 0 0,0 0 0,0 0 0,1 0 0,-1 0 0,0 0 0,1 0 0,-1 0 0,1-1 0,-1 1 0,1 0 0,0-1 0,0 0 0,0 1 0,0-1 0,0 0 0,0 0 0,0 0 0,0 0 0,0-1 0,1 1 0,3 0 0,2 1 0,0-1 0,0 0 0,15-1 0,4 1 0,-26-1 0,-1 0 0,0 0 0,0 0 0,0 0 0,0 1 0,0-1 0,1 0 0,-1 0 0,0 0 0,0 1 0,0-1 0,0 0 0,0 0 0,0 1 0,0-1 0,0 0 0,0 0 0,0 0 0,0 1 0,0-1 0,0 0 0,0 0 0,0 1 0,0-1 0,0 0 0,0 0 0,0 1 0,0-1 0,0 0 0,0 0 0,0 0 0,-1 1 0,1-1 0,0 0 0,0 0 0,0 0 0,0 0 0,0 1 0,-1-1 0,1 0 0,0 0 0,0 0 0,0 0 0,-1 0 0,1 0 0,0 1 0,-12 13 0,9-11 0,-1 3 0,-1 0 0,1 0 0,0 1 0,1 0 0,0 0 0,0 0 0,0 0 0,1 0 0,0 1 0,1-1 0,-2 14 0,1 7 0,4 54 0,0-23 0,5 47 0,0-1 0,-6-84 0,0-7 0,-1 0 0,-1 0 0,0 0 0,-1-1 0,-3 17 0,4-26 0,-1-1 0,1 1 0,-1 0 0,0-1 0,0 1 0,0-1 0,0 0 0,0 0 0,-1 0 0,0 0 0,1 0 0,-1 0 0,0-1 0,0 1 0,-1-1 0,1 0 0,0 0 0,-1 0 0,1 0 0,-1-1 0,0 0 0,-7 3 0,9-4-105,0 1 0,0-1 0,0 1 0,-1-1 0,1 0 0,0 0 0,0 0 0,-1 0 0,1 0 0,0-1 0,0 1 0,-3-1 0,-6-5-6721</inkml:trace>
 </inkml:ink>
 </file>
 
@@ -678,22 +680,23 @@
         <inkml:traceFormat>
           <inkml:channel name="X" type="integer" min="-2.14748E9" max="2.14748E9" units="cm"/>
           <inkml:channel name="Y" type="integer" min="-2.14748E9" max="2.14748E9" units="cm"/>
+          <inkml:channel name="F" type="integer" max="32767" units="dev"/>
         </inkml:traceFormat>
         <inkml:channelProperties>
           <inkml:channelProperty channel="X" name="resolution" value="1000" units="1/cm"/>
           <inkml:channelProperty channel="Y" name="resolution" value="1000" units="1/cm"/>
+          <inkml:channelProperty channel="F" name="resolution" value="0" units="1/dev"/>
         </inkml:channelProperties>
       </inkml:inkSource>
-      <inkml:timestamp xml:id="ts0" timeString="2023-01-17T15:32:45.724"/>
+      <inkml:timestamp xml:id="ts0" timeString="2026-01-09T19:01:44.869"/>
     </inkml:context>
     <inkml:brush xml:id="br0">
-      <inkml:brushProperty name="width" value="0.2" units="cm"/>
-      <inkml:brushProperty name="height" value="0.2" units="cm"/>
+      <inkml:brushProperty name="width" value="0.035" units="cm"/>
+      <inkml:brushProperty name="height" value="0.035" units="cm"/>
       <inkml:brushProperty name="color" value="#E71224"/>
-      <inkml:brushProperty name="ignorePressure" value="1"/>
     </inkml:brush>
   </inkml:definitions>
-  <inkml:trace contextRef="#ctx0" brushRef="#br0">1 1,'3565'0,"-3529"0</inkml:trace>
+  <inkml:trace contextRef="#ctx0" brushRef="#br0">13 62 24575,'-12'2'0,"12"2"0,2-3 0,-1 0 0,1 0 0,0 0 0,-1 0 0,1-1 0,0 1 0,0-1 0,-1 1 0,4-1 0,55 4 0,61-5 0,-39 0 0,159-7 0,-85 1 0,477-7 0,-219 0 0,75-1 0,-118 6 0,-232 4 0,-99 3-1365,-7-1-5461</inkml:trace>
 </inkml:ink>
 </file>
 
@@ -705,22 +708,23 @@
         <inkml:traceFormat>
           <inkml:channel name="X" type="integer" min="-2.14748E9" max="2.14748E9" units="cm"/>
           <inkml:channel name="Y" type="integer" min="-2.14748E9" max="2.14748E9" units="cm"/>
+          <inkml:channel name="F" type="integer" max="32767" units="dev"/>
         </inkml:traceFormat>
         <inkml:channelProperties>
           <inkml:channelProperty channel="X" name="resolution" value="1000" units="1/cm"/>
           <inkml:channelProperty channel="Y" name="resolution" value="1000" units="1/cm"/>
+          <inkml:channelProperty channel="F" name="resolution" value="0" units="1/dev"/>
         </inkml:channelProperties>
       </inkml:inkSource>
-      <inkml:timestamp xml:id="ts0" timeString="2023-01-17T15:32:48.752"/>
+      <inkml:timestamp xml:id="ts0" timeString="2026-01-09T19:01:45.551"/>
     </inkml:context>
     <inkml:brush xml:id="br0">
-      <inkml:brushProperty name="width" value="0.2" units="cm"/>
-      <inkml:brushProperty name="height" value="0.2" units="cm"/>
+      <inkml:brushProperty name="width" value="0.035" units="cm"/>
+      <inkml:brushProperty name="height" value="0.035" units="cm"/>
       <inkml:brushProperty name="color" value="#E71224"/>
-      <inkml:brushProperty name="ignorePressure" value="1"/>
     </inkml:brush>
   </inkml:definitions>
-  <inkml:trace contextRef="#ctx0" brushRef="#br0">0 1,'12367'0,"-12341"0</inkml:trace>
+  <inkml:trace contextRef="#ctx0" brushRef="#br0">0 1 24575,'5'1'0,"-1"0"0,0 0 0,1 1 0,-1 0 0,0-1 0,0 1 0,0 1 0,0-1 0,3 4 0,13 6 0,72 23 0,-69-28 0,0 1 0,-1 2 0,37 20 0,-56-29 0,0 1 0,0 0 0,-1 0 0,1 1 0,0-1 0,-1 0 0,1 1 0,-1-1 0,0 1 0,0 0 0,0 0 0,0 0 0,-1 0 0,1 0 0,-1 0 0,0 1 0,0-1 0,0 0 0,0 1 0,0-1 0,-1 0 0,1 1 0,-1-1 0,0 1 0,0-1 0,-1 1 0,1-1 0,-2 5 0,0-1 0,0-1 0,-1 1 0,0-1 0,0 0 0,0 0 0,-1-1 0,0 1 0,0-1 0,-1 1 0,1-1 0,-1-1 0,0 1 0,-9 6 0,-31 17-1365,25-15-5461</inkml:trace>
 </inkml:ink>
 </file>
 
@@ -732,22 +736,23 @@
         <inkml:traceFormat>
           <inkml:channel name="X" type="integer" min="-2.14748E9" max="2.14748E9" units="cm"/>
           <inkml:channel name="Y" type="integer" min="-2.14748E9" max="2.14748E9" units="cm"/>
+          <inkml:channel name="F" type="integer" max="32767" units="dev"/>
         </inkml:traceFormat>
         <inkml:channelProperties>
           <inkml:channelProperty channel="X" name="resolution" value="1000" units="1/cm"/>
           <inkml:channelProperty channel="Y" name="resolution" value="1000" units="1/cm"/>
+          <inkml:channelProperty channel="F" name="resolution" value="0" units="1/dev"/>
         </inkml:channelProperties>
       </inkml:inkSource>
-      <inkml:timestamp xml:id="ts0" timeString="2023-01-17T15:32:54.381"/>
+      <inkml:timestamp xml:id="ts0" timeString="2026-02-10T17:26:50.112"/>
     </inkml:context>
     <inkml:brush xml:id="br0">
-      <inkml:brushProperty name="width" value="0.2" units="cm"/>
-      <inkml:brushProperty name="height" value="0.2" units="cm"/>
+      <inkml:brushProperty name="width" value="0.035" units="cm"/>
+      <inkml:brushProperty name="height" value="0.035" units="cm"/>
       <inkml:brushProperty name="color" value="#E71224"/>
-      <inkml:brushProperty name="ignorePressure" value="1"/>
     </inkml:brush>
   </inkml:definitions>
-  <inkml:trace contextRef="#ctx0" brushRef="#br0">0 0,'13232'0,"-13196"0</inkml:trace>
+  <inkml:trace contextRef="#ctx0" brushRef="#br0">1 4 24575,'33'0'0,"-19"-3"0,3 3 0,-1 0 0,18 9 0,-29-6 0,1 0 0,0 0 0,-2 0 0,2 0 0,-2 3 0,2-1 0,-1-2 0,-1 3 0,1 3 0,-1-3 0,1 0 0,7 18 0,8 20 0,17 33 0,-1 3 0,37 109 0,-66-166 0,-1 1 0,0 3 0,-2-4 0,2 4 0,-3-1 0,2 1 0,-2 0 0,1 38 0,-1 20 0,-3 119 0,-1-68 0,-1-100 0,-1-4 0,0 3 0,-1-2 0,-1 2 0,-1-2 0,1-1 0,-1-2 0,-2 3 0,-16 46 0,1 10 0,6-15 0,4 0 0,-15 124 0,19-136 0,6-48 0,1 1 0,1 0 0,-1 0 0,1 0 0,1-1 0,0 1 0,0 0 0,0 0 0,3 29 0,-3-38 0,1 0 0,1 0 0,-1 0 0,1 0 0,1-1 0,-2 1 0,1 0 0,1 0 0,-2 0 0,2-3 0,-1 3 0,1 0 0,0-3 0,0 0 0,0 3 0,0-3 0,0 0 0,0 0 0,0 0 0,-1-1 0,1-2 0,2 3 0,4 0 0,3 3 0,0-3 0,-1 0 0,24-3 0,5 3 0,-39-3 0,-1 0 0,0 0 0,0 0 0,0 0 0,0 3 0,0-3 0,2 0 0,-2 0 0,0 0 0,0 3 0,0-3 0,0 0 0,0 0 0,0 3 0,0-3 0,0 0 0,0 0 0,0 0 0,0 3 0,0-3 0,0 0 0,0 0 0,0 3 0,0-3 0,0 0 0,0 0 0,0 3 0,0-3 0,0 0 0,0 0 0,0 0 0,-2 3 0,2-3 0,0 0 0,0 0 0,0 0 0,0 0 0,0 3 0,-1-3 0,1 0 0,0 0 0,0 0 0,0 0 0,-2 0 0,2 0 0,0 3 0,-18 38 0,14-32 0,-2 9 0,-1-1 0,1 1 0,0 3 0,1 0 0,1-1 0,-1 1 0,1 0 0,1-1 0,0 4 0,1-3 0,-2 41 0,1 20 0,6 161 0,0-69 0,7 139 0,1-3 0,-10-247 0,1-22 0,-2 0 0,-2 1 0,1-1 0,-2-3 0,-5 51 0,7-77 0,-2-3 0,1 3 0,-1-1 0,0-2 0,0 3 0,1-3 0,-1 0 0,0 0 0,-2 0 0,1-1 0,1 1 0,-2 0 0,1-3 0,-1 3 0,-1-3 0,2 0 0,0 0 0,-2 0 0,1-1 0,-1-2 0,0 0 0,-10 9 0,13-12-105,0 3 0,0-3 0,0 3 0,-1-3 0,1 0 0,0 0 0,0 0 0,-2 0 0,2 0 0,0-3 0,0 3 0,-4-3 0,-9-15-6721</inkml:trace>
 </inkml:ink>
 </file>
 
@@ -786,6 +791,170 @@
         <inkml:traceFormat>
           <inkml:channel name="X" type="integer" min="-2.14748E9" max="2.14748E9" units="cm"/>
           <inkml:channel name="Y" type="integer" min="-2.14748E9" max="2.14748E9" units="cm"/>
+          <inkml:channel name="F" type="integer" max="32767" units="dev"/>
+        </inkml:traceFormat>
+        <inkml:channelProperties>
+          <inkml:channelProperty channel="X" name="resolution" value="1000" units="1/cm"/>
+          <inkml:channelProperty channel="Y" name="resolution" value="1000" units="1/cm"/>
+          <inkml:channelProperty channel="F" name="resolution" value="0" units="1/dev"/>
+        </inkml:channelProperties>
+      </inkml:inkSource>
+      <inkml:timestamp xml:id="ts0" timeString="2026-02-10T17:26:50.113"/>
+    </inkml:context>
+    <inkml:brush xml:id="br0">
+      <inkml:brushProperty name="width" value="0.035" units="cm"/>
+      <inkml:brushProperty name="height" value="0.035" units="cm"/>
+      <inkml:brushProperty name="color" value="#E71224"/>
+    </inkml:brush>
+  </inkml:definitions>
+  <inkml:trace contextRef="#ctx0" brushRef="#br0">19 183 24575,'-18'6'0,"18"6"0,3-9 0,-2 0 0,2 0 0,0 0 0,-1 0 0,1-3 0,0 3 0,0-3 0,-2 3 0,7-3 0,81 11 0,90-14 0,-57 1 0,236-22 0,-127 3 0,709-20 0,-326-1 0,112-2 0,-175 18 0,-345 11 0,-147 9-1365,-10-3-5461</inkml:trace>
+</inkml:ink>
+</file>
+
+<file path=ppt/ink/ink31.xml><?xml version="1.0" encoding="utf-8"?>
+<inkml:ink xmlns:inkml="http://www.w3.org/2003/InkML">
+  <inkml:definitions>
+    <inkml:context xml:id="ctx0">
+      <inkml:inkSource xml:id="inkSrc0">
+        <inkml:traceFormat>
+          <inkml:channel name="X" type="integer" min="-2.14748E9" max="2.14748E9" units="cm"/>
+          <inkml:channel name="Y" type="integer" min="-2.14748E9" max="2.14748E9" units="cm"/>
+          <inkml:channel name="F" type="integer" max="32767" units="dev"/>
+        </inkml:traceFormat>
+        <inkml:channelProperties>
+          <inkml:channelProperty channel="X" name="resolution" value="1000" units="1/cm"/>
+          <inkml:channelProperty channel="Y" name="resolution" value="1000" units="1/cm"/>
+          <inkml:channelProperty channel="F" name="resolution" value="0" units="1/dev"/>
+        </inkml:channelProperties>
+      </inkml:inkSource>
+      <inkml:timestamp xml:id="ts0" timeString="2026-02-10T17:26:50.114"/>
+    </inkml:context>
+    <inkml:brush xml:id="br0">
+      <inkml:brushProperty name="width" value="0.035" units="cm"/>
+      <inkml:brushProperty name="height" value="0.035" units="cm"/>
+      <inkml:brushProperty name="color" value="#E71224"/>
+    </inkml:brush>
+  </inkml:definitions>
+  <inkml:trace contextRef="#ctx0" brushRef="#br0">0 1 24575,'7'3'0,"-1"0"0,0 0 0,2 3 0,-2 0 0,0-3 0,0 3 0,-1 2 0,1-2 0,5 12 0,18 18 0,108 67 0,-103-82 0,0 2 0,-1 7 0,55 58 0,-84-85 0,0 3 0,1 0 0,-2 0 0,1 3 0,1-3 0,-2 0 0,1 3 0,-1-3 0,0 2 0,0 1 0,0 0 0,0 0 0,-2 0 0,2 0 0,-1 0 0,-1 2 0,1-2 0,-1 0 0,1 3 0,-1-3 0,-1 0 0,2 3 0,-2-4 0,0 4 0,0-3 0,-2 3 0,2-3 0,-3 14 0,0-2 0,0-3 0,-1 3 0,0-4 0,-1 1 0,1 0 0,-2-4 0,0 4 0,0-3 0,-2 3 0,2-4 0,-1-2 0,0 3 0,-14 18 0,-46 49-1365,37-43-5461</inkml:trace>
+</inkml:ink>
+</file>
+
+<file path=ppt/ink/ink32.xml><?xml version="1.0" encoding="utf-8"?>
+<inkml:ink xmlns:inkml="http://www.w3.org/2003/InkML">
+  <inkml:definitions>
+    <inkml:context xml:id="ctx0">
+      <inkml:inkSource xml:id="inkSrc0">
+        <inkml:traceFormat>
+          <inkml:channel name="X" type="integer" min="-2.14748E9" max="2.14748E9" units="cm"/>
+          <inkml:channel name="Y" type="integer" min="-2.14748E9" max="2.14748E9" units="cm"/>
+        </inkml:traceFormat>
+        <inkml:channelProperties>
+          <inkml:channelProperty channel="X" name="resolution" value="1000" units="1/cm"/>
+          <inkml:channelProperty channel="Y" name="resolution" value="1000" units="1/cm"/>
+        </inkml:channelProperties>
+      </inkml:inkSource>
+      <inkml:timestamp xml:id="ts0" timeString="2023-01-17T15:32:29.124"/>
+    </inkml:context>
+    <inkml:brush xml:id="br0">
+      <inkml:brushProperty name="width" value="0.2" units="cm"/>
+      <inkml:brushProperty name="height" value="0.2" units="cm"/>
+      <inkml:brushProperty name="color" value="#E71224"/>
+      <inkml:brushProperty name="ignorePressure" value="1"/>
+    </inkml:brush>
+  </inkml:definitions>
+  <inkml:trace contextRef="#ctx0" brushRef="#br0">0 0,'12824'0,"-12790"0</inkml:trace>
+</inkml:ink>
+</file>
+
+<file path=ppt/ink/ink33.xml><?xml version="1.0" encoding="utf-8"?>
+<inkml:ink xmlns:inkml="http://www.w3.org/2003/InkML">
+  <inkml:definitions>
+    <inkml:context xml:id="ctx0">
+      <inkml:inkSource xml:id="inkSrc0">
+        <inkml:traceFormat>
+          <inkml:channel name="X" type="integer" min="-2.14748E9" max="2.14748E9" units="cm"/>
+          <inkml:channel name="Y" type="integer" min="-2.14748E9" max="2.14748E9" units="cm"/>
+        </inkml:traceFormat>
+        <inkml:channelProperties>
+          <inkml:channelProperty channel="X" name="resolution" value="1000" units="1/cm"/>
+          <inkml:channelProperty channel="Y" name="resolution" value="1000" units="1/cm"/>
+        </inkml:channelProperties>
+      </inkml:inkSource>
+      <inkml:timestamp xml:id="ts0" timeString="2023-01-17T15:32:45.724"/>
+    </inkml:context>
+    <inkml:brush xml:id="br0">
+      <inkml:brushProperty name="width" value="0.2" units="cm"/>
+      <inkml:brushProperty name="height" value="0.2" units="cm"/>
+      <inkml:brushProperty name="color" value="#E71224"/>
+      <inkml:brushProperty name="ignorePressure" value="1"/>
+    </inkml:brush>
+  </inkml:definitions>
+  <inkml:trace contextRef="#ctx0" brushRef="#br0">1 1,'3565'0,"-3529"0</inkml:trace>
+</inkml:ink>
+</file>
+
+<file path=ppt/ink/ink34.xml><?xml version="1.0" encoding="utf-8"?>
+<inkml:ink xmlns:inkml="http://www.w3.org/2003/InkML">
+  <inkml:definitions>
+    <inkml:context xml:id="ctx0">
+      <inkml:inkSource xml:id="inkSrc0">
+        <inkml:traceFormat>
+          <inkml:channel name="X" type="integer" min="-2.14748E9" max="2.14748E9" units="cm"/>
+          <inkml:channel name="Y" type="integer" min="-2.14748E9" max="2.14748E9" units="cm"/>
+        </inkml:traceFormat>
+        <inkml:channelProperties>
+          <inkml:channelProperty channel="X" name="resolution" value="1000" units="1/cm"/>
+          <inkml:channelProperty channel="Y" name="resolution" value="1000" units="1/cm"/>
+        </inkml:channelProperties>
+      </inkml:inkSource>
+      <inkml:timestamp xml:id="ts0" timeString="2023-01-17T15:32:48.752"/>
+    </inkml:context>
+    <inkml:brush xml:id="br0">
+      <inkml:brushProperty name="width" value="0.2" units="cm"/>
+      <inkml:brushProperty name="height" value="0.2" units="cm"/>
+      <inkml:brushProperty name="color" value="#E71224"/>
+      <inkml:brushProperty name="ignorePressure" value="1"/>
+    </inkml:brush>
+  </inkml:definitions>
+  <inkml:trace contextRef="#ctx0" brushRef="#br0">0 1,'12367'0,"-12341"0</inkml:trace>
+</inkml:ink>
+</file>
+
+<file path=ppt/ink/ink35.xml><?xml version="1.0" encoding="utf-8"?>
+<inkml:ink xmlns:inkml="http://www.w3.org/2003/InkML">
+  <inkml:definitions>
+    <inkml:context xml:id="ctx0">
+      <inkml:inkSource xml:id="inkSrc0">
+        <inkml:traceFormat>
+          <inkml:channel name="X" type="integer" min="-2.14748E9" max="2.14748E9" units="cm"/>
+          <inkml:channel name="Y" type="integer" min="-2.14748E9" max="2.14748E9" units="cm"/>
+        </inkml:traceFormat>
+        <inkml:channelProperties>
+          <inkml:channelProperty channel="X" name="resolution" value="1000" units="1/cm"/>
+          <inkml:channelProperty channel="Y" name="resolution" value="1000" units="1/cm"/>
+        </inkml:channelProperties>
+      </inkml:inkSource>
+      <inkml:timestamp xml:id="ts0" timeString="2023-01-17T15:32:54.381"/>
+    </inkml:context>
+    <inkml:brush xml:id="br0">
+      <inkml:brushProperty name="width" value="0.2" units="cm"/>
+      <inkml:brushProperty name="height" value="0.2" units="cm"/>
+      <inkml:brushProperty name="color" value="#E71224"/>
+      <inkml:brushProperty name="ignorePressure" value="1"/>
+    </inkml:brush>
+  </inkml:definitions>
+  <inkml:trace contextRef="#ctx0" brushRef="#br0">0 0,'13232'0,"-13196"0</inkml:trace>
+</inkml:ink>
+</file>
+
+<file path=ppt/ink/ink36.xml><?xml version="1.0" encoding="utf-8"?>
+<inkml:ink xmlns:inkml="http://www.w3.org/2003/InkML">
+  <inkml:definitions>
+    <inkml:context xml:id="ctx0">
+      <inkml:inkSource xml:id="inkSrc0">
+        <inkml:traceFormat>
+          <inkml:channel name="X" type="integer" min="-2.14748E9" max="2.14748E9" units="cm"/>
+          <inkml:channel name="Y" type="integer" min="-2.14748E9" max="2.14748E9" units="cm"/>
         </inkml:traceFormat>
         <inkml:channelProperties>
           <inkml:channelProperty channel="X" name="resolution" value="1000" units="1/cm"/>
@@ -805,7 +974,7 @@
 </inkml:ink>
 </file>
 
-<file path=ppt/ink/ink31.xml><?xml version="1.0" encoding="utf-8"?>
+<file path=ppt/ink/ink37.xml><?xml version="1.0" encoding="utf-8"?>
 <inkml:ink xmlns:inkml="http://www.w3.org/2003/InkML">
   <inkml:definitions>
     <inkml:context xml:id="ctx0">
@@ -833,7 +1002,7 @@
 </inkml:ink>
 </file>
 
-<file path=ppt/ink/ink32.xml><?xml version="1.0" encoding="utf-8"?>
+<file path=ppt/ink/ink38.xml><?xml version="1.0" encoding="utf-8"?>
 <inkml:ink xmlns:inkml="http://www.w3.org/2003/InkML">
   <inkml:definitions>
     <inkml:context xml:id="ctx0">
@@ -861,7 +1030,7 @@
 </inkml:ink>
 </file>
 
-<file path=ppt/ink/ink33.xml><?xml version="1.0" encoding="utf-8"?>
+<file path=ppt/ink/ink39.xml><?xml version="1.0" encoding="utf-8"?>
 <inkml:ink xmlns:inkml="http://www.w3.org/2003/InkML">
   <inkml:definitions>
     <inkml:context xml:id="ctx0">
@@ -886,146 +1055,6 @@
     </inkml:brush>
   </inkml:definitions>
   <inkml:trace contextRef="#ctx0" brushRef="#br0">1 1 24575,'3'1'0,"-1"-1"0,1 1 0,0 0 0,-1 0 0,1 1 0,0-1 0,-1 0 0,0 1 0,1 0 0,-1-1 0,3 4 0,8 5 0,135 88 0,-117-77-480,0 2 0,52 52 0,-11-9-54,20 18-125,15 13 253,15 17 406,-28-23 0,36 42-1433,-54-51 169,-43-49 653,239 258-652,-164-182 1051,-7-7 249,-43-36-904,105 92-1,-75-80 505,28 25 213,-31-33-248,36 27 45,157 66 860,-208-131-634,1-4 0,1-2 0,91 18-1,-118-35 5,1-1-1,63 2 1,93-9 739,-186-1-528,33-1 2173</inkml:trace>
-</inkml:ink>
-</file>
-
-<file path=ppt/ink/ink34.xml><?xml version="1.0" encoding="utf-8"?>
-<inkml:ink xmlns:inkml="http://www.w3.org/2003/InkML">
-  <inkml:definitions>
-    <inkml:context xml:id="ctx0">
-      <inkml:inkSource xml:id="inkSrc0">
-        <inkml:traceFormat>
-          <inkml:channel name="X" type="integer" min="-2.14748E9" max="2.14748E9" units="cm"/>
-          <inkml:channel name="Y" type="integer" min="-2.14748E9" max="2.14748E9" units="cm"/>
-          <inkml:channel name="F" type="integer" max="32767" units="dev"/>
-        </inkml:traceFormat>
-        <inkml:channelProperties>
-          <inkml:channelProperty channel="X" name="resolution" value="1000" units="1/cm"/>
-          <inkml:channelProperty channel="Y" name="resolution" value="1000" units="1/cm"/>
-          <inkml:channelProperty channel="F" name="resolution" value="0" units="1/dev"/>
-        </inkml:channelProperties>
-      </inkml:inkSource>
-      <inkml:timestamp xml:id="ts0" timeString="2023-01-19T17:57:02.523"/>
-    </inkml:context>
-    <inkml:brush xml:id="br0">
-      <inkml:brushProperty name="width" value="0.2" units="cm"/>
-      <inkml:brushProperty name="height" value="0.2" units="cm"/>
-      <inkml:brushProperty name="color" value="#E71224"/>
-    </inkml:brush>
-  </inkml:definitions>
-  <inkml:trace contextRef="#ctx0" brushRef="#br0">1 1959 24575,'1'-1'0,"1"1"0,-1 0 0,1-1 0,0 1 0,-1-1 0,1 1 0,-1-1 0,1 0 0,-1 0 0,0 1 0,1-1 0,-1 0 0,0 0 0,1 0 0,-1-1 0,0 1 0,0 0 0,0 0 0,0-1 0,0 1 0,0 0 0,-1-1 0,1 1 0,0-1 0,0-1 0,3-7 0,-1 0 0,4-19 0,-4 16 0,3-14 0,2 0 0,1 0 0,14-30 0,16-35 0,-30 65 0,2 1 0,1 0 0,30-46 0,-35 60 0,0 0 0,11-25 0,-12 22 0,16-26 0,-2 8 0,19-25 0,-5 9 0,-24 34 0,0 0 0,0 1 0,14-13 0,-15 16 0,1-1 0,-2 0 0,1-1 0,-2 1 0,7-16 0,20-31 0,-12 25 0,-2-1 0,22-51 0,17-33 0,-53 106 0,2 0 0,0 1 0,0 0 0,19-19 0,-15 16 0,21-28 0,-19 22 0,1 1 0,26-27 0,-21 25 0,18-27 0,-25 34 0,1-1 0,0 1 0,24-19 0,21-22 0,-16 5 0,-20 22 0,2 1 0,0 1 0,32-25 0,-31 32 93,96-78-1551</inkml:trace>
-</inkml:ink>
-</file>
-
-<file path=ppt/ink/ink35.xml><?xml version="1.0" encoding="utf-8"?>
-<inkml:ink xmlns:inkml="http://www.w3.org/2003/InkML">
-  <inkml:definitions>
-    <inkml:context xml:id="ctx0">
-      <inkml:inkSource xml:id="inkSrc0">
-        <inkml:traceFormat>
-          <inkml:channel name="X" type="integer" min="-2.14748E9" max="2.14748E9" units="cm"/>
-          <inkml:channel name="Y" type="integer" min="-2.14748E9" max="2.14748E9" units="cm"/>
-          <inkml:channel name="F" type="integer" max="32767" units="dev"/>
-        </inkml:traceFormat>
-        <inkml:channelProperties>
-          <inkml:channelProperty channel="X" name="resolution" value="1000" units="1/cm"/>
-          <inkml:channelProperty channel="Y" name="resolution" value="1000" units="1/cm"/>
-          <inkml:channelProperty channel="F" name="resolution" value="0" units="1/dev"/>
-        </inkml:channelProperties>
-      </inkml:inkSource>
-      <inkml:timestamp xml:id="ts0" timeString="2023-01-19T17:57:03.985"/>
-    </inkml:context>
-    <inkml:brush xml:id="br0">
-      <inkml:brushProperty name="width" value="0.2" units="cm"/>
-      <inkml:brushProperty name="height" value="0.2" units="cm"/>
-      <inkml:brushProperty name="color" value="#E71224"/>
-    </inkml:brush>
-  </inkml:definitions>
-  <inkml:trace contextRef="#ctx0" brushRef="#br0">1 1 24575,'4'2'0,"1"0"0,0 1 0,-1-1 0,1 1 0,-1 0 0,0 0 0,0 1 0,0 0 0,-1-1 0,5 6 0,6 11 0,0 1 0,-2 1 0,0 0 0,11 29 0,26 77 0,-41-108 0,-1 0 0,0 0 0,-2 0 0,5 36 0,-5-11 0,-2 53 0,-3-87 0,1-1 0,0 1 0,1 0 0,0 0 0,1-1 0,0 1 0,0-1 0,1 0 0,1 0 0,-1 0 0,2-1 0,-1 1 0,13 13 0,0 0 0,-13-16 0,1 0 0,-1-1 0,11 9 0,-13-12 0,0-1 0,0 0 0,1-1 0,-1 1 0,0-1 0,1 1 0,-1-1 0,1 0 0,-1 0 0,1 0 0,6 0 0,-3-1 0,-1 0 0,0 0 0,0-1 0,0 0 0,0 0 0,0-1 0,-1 1 0,1-1 0,0 0 0,7-4 0,6-5 0,28-20 0,2-1 0,-22 16 0,-13 8 0,1-1 0,0 2 0,25-9 0,0 2 0,49-25 0,-61 26 0,90-47 0,-105 53 9,1-1 0,14-11-1,-10 6-1399</inkml:trace>
-</inkml:ink>
-</file>
-
-<file path=ppt/ink/ink36.xml><?xml version="1.0" encoding="utf-8"?>
-<inkml:ink xmlns:inkml="http://www.w3.org/2003/InkML">
-  <inkml:definitions>
-    <inkml:context xml:id="ctx0">
-      <inkml:inkSource xml:id="inkSrc0">
-        <inkml:traceFormat>
-          <inkml:channel name="X" type="integer" min="-2.14748E9" max="2.14748E9" units="cm"/>
-          <inkml:channel name="Y" type="integer" min="-2.14748E9" max="2.14748E9" units="cm"/>
-          <inkml:channel name="F" type="integer" max="32767" units="dev"/>
-        </inkml:traceFormat>
-        <inkml:channelProperties>
-          <inkml:channelProperty channel="X" name="resolution" value="1000" units="1/cm"/>
-          <inkml:channelProperty channel="Y" name="resolution" value="1000" units="1/cm"/>
-          <inkml:channelProperty channel="F" name="resolution" value="0" units="1/dev"/>
-        </inkml:channelProperties>
-      </inkml:inkSource>
-      <inkml:timestamp xml:id="ts0" timeString="2023-01-19T17:57:06.448"/>
-    </inkml:context>
-    <inkml:brush xml:id="br0">
-      <inkml:brushProperty name="width" value="0.2" units="cm"/>
-      <inkml:brushProperty name="height" value="0.2" units="cm"/>
-      <inkml:brushProperty name="color" value="#E71224"/>
-    </inkml:brush>
-  </inkml:definitions>
-  <inkml:trace contextRef="#ctx0" brushRef="#br0">0 1 24575,'0'2'0,"1"0"0,-1 0 0,1 1 0,0-1 0,-1 0 0,1 0 0,0 0 0,0 0 0,0 0 0,1 0 0,-1 0 0,0 0 0,2 1 0,25 25 0,-20-20 0,35 34 0,77 69 0,-109-102 0,-1 0 0,0 1 0,-1 0 0,0 1 0,0 0 0,-1 0 0,-1 1 0,0 0 0,8 19 0,-8-13 0,-2-1 0,0 1 0,0 0 0,-2 1 0,0-1 0,0 31 0,-2-33 0,1 0 0,1-1 0,0 1 0,7 15 0,-5-13 0,0 0 0,3 32 0,2 33 0,2 41 0,-12 301 0,-1-194 0,0-197 0,-10 49 0,3-22 0,8-56-114,-1 0 1,0 0-1,1 0 0,-2 1 0,1-1 1,0 0-1,-1-1 0,0 1 0,0 0 1,-1 0-1,-2 3 0</inkml:trace>
-</inkml:ink>
-</file>
-
-<file path=ppt/ink/ink37.xml><?xml version="1.0" encoding="utf-8"?>
-<inkml:ink xmlns:inkml="http://www.w3.org/2003/InkML">
-  <inkml:definitions>
-    <inkml:context xml:id="ctx0">
-      <inkml:inkSource xml:id="inkSrc0">
-        <inkml:traceFormat>
-          <inkml:channel name="X" type="integer" min="-2.14748E9" max="2.14748E9" units="cm"/>
-          <inkml:channel name="Y" type="integer" min="-2.14748E9" max="2.14748E9" units="cm"/>
-          <inkml:channel name="F" type="integer" max="32767" units="dev"/>
-        </inkml:traceFormat>
-        <inkml:channelProperties>
-          <inkml:channelProperty channel="X" name="resolution" value="1000" units="1/cm"/>
-          <inkml:channelProperty channel="Y" name="resolution" value="1000" units="1/cm"/>
-          <inkml:channelProperty channel="F" name="resolution" value="0" units="1/dev"/>
-        </inkml:channelProperties>
-      </inkml:inkSource>
-      <inkml:timestamp xml:id="ts0" timeString="2023-01-19T17:57:07.493"/>
-    </inkml:context>
-    <inkml:brush xml:id="br0">
-      <inkml:brushProperty name="width" value="0.2" units="cm"/>
-      <inkml:brushProperty name="height" value="0.2" units="cm"/>
-      <inkml:brushProperty name="color" value="#E71224"/>
-    </inkml:brush>
-  </inkml:definitions>
-  <inkml:trace contextRef="#ctx0" brushRef="#br0">1 1554 24575,'0'-5'0,"1"0"0,0 1 0,0-1 0,0 0 0,1 0 0,0 1 0,0-1 0,0 1 0,0 0 0,4-5 0,31-42 0,-29 41 0,26-33-976,72-69 1,101-102 975,-192 200 0,0 0 0,1 0 0,1 2 0,19-12 0,13-10 0,10-9-705,122-66 0,-123 78 705,63-30 0,98-41 0,-141 63 0,34-3-946,-62 24 663,85-40-1326,-37 22 1415,-16 6 183,125-44-85,-108 39 96,117-25 0,-95 29 0,21-2-11,9-2 65,-102 23 162,-31 8-217,1 0 0,19-8 0,149-66 2905,-162 68-7755</inkml:trace>
-</inkml:ink>
-</file>
-
-<file path=ppt/ink/ink38.xml><?xml version="1.0" encoding="utf-8"?>
-<inkml:ink xmlns:inkml="http://www.w3.org/2003/InkML">
-  <inkml:definitions>
-    <inkml:context xml:id="ctx0">
-      <inkml:inkSource xml:id="inkSrc0">
-        <inkml:traceFormat>
-          <inkml:channel name="X" type="integer" min="-2.14748E9" max="2.14748E9" units="cm"/>
-          <inkml:channel name="Y" type="integer" min="-2.14748E9" max="2.14748E9" units="cm"/>
-          <inkml:channel name="F" type="integer" max="32767" units="dev"/>
-        </inkml:traceFormat>
-        <inkml:channelProperties>
-          <inkml:channelProperty channel="X" name="resolution" value="1000" units="1/cm"/>
-          <inkml:channelProperty channel="Y" name="resolution" value="1000" units="1/cm"/>
-          <inkml:channelProperty channel="F" name="resolution" value="0" units="1/dev"/>
-        </inkml:channelProperties>
-      </inkml:inkSource>
-      <inkml:timestamp xml:id="ts0" timeString="2023-01-19T17:57:09.351"/>
-    </inkml:context>
-    <inkml:brush xml:id="br0">
-      <inkml:brushProperty name="width" value="0.2" units="cm"/>
-      <inkml:brushProperty name="height" value="0.2" units="cm"/>
-      <inkml:brushProperty name="color" value="#E71224"/>
-    </inkml:brush>
-  </inkml:definitions>
-  <inkml:trace contextRef="#ctx0" brushRef="#br0">0 0 24575,'36'12'0,"10"-6"0,1-2 0,0-3 0,48-3 0,-12 0 0,423 2 0,-492 1 0,0 1 0,0 0 0,0 1 0,-1 1 0,17 6 0,23 5 0,-50-14 0,-1-1 0,1 1 0,0 0 0,-1-1 0,1 1 0,-1 1 0,1-1 0,-1 0 0,1 1 0,-1-1 0,0 1 0,0-1 0,1 1 0,-1 0 0,0 0 0,-1 0 0,1 0 0,0 1 0,-1-1 0,1 0 0,-1 1 0,0-1 0,0 1 0,2 5 0,-2-3 0,-1 0 0,1 0 0,-1 0 0,0 0 0,-1 0 0,1 1 0,-1-1 0,0 0 0,0 0 0,-1 0 0,0 0 0,-3 7 0,-130 285 0,55-153 0,24-52 0,39-67 0,1 1 0,1 1 0,-12 31 0,-12 25-1365</inkml:trace>
 </inkml:ink>
 </file>
 
@@ -1054,6 +1083,146 @@
     </inkml:brush>
   </inkml:definitions>
   <inkml:trace contextRef="#ctx0" brushRef="#br0">47 426 24575,'-1'-4'0,"0"1"0,0-1 0,0 1 0,-1-1 0,1 1 0,-1 0 0,0 0 0,0 0 0,-4-5 0,-6-11 0,9 10 0,0 0 0,0 0 0,1 0 0,0 0 0,1 0 0,0-1 0,0-9 0,5-68 0,-3 79 0,0-1 0,1 1 0,0-1 0,0 1 0,1 0 0,0 0 0,0 0 0,1 0 0,0 0 0,0 1 0,1 0 0,0 0 0,0 0 0,1 0 0,0 1 0,0 0 0,0 0 0,1 1 0,0 0 0,11-7 0,-8 6 0,0 1 0,1-1 0,-1 2 0,1-1 0,0 2 0,0-1 0,0 2 0,1-1 0,-1 1 0,1 1 0,0 0 0,-1 1 0,1 0 0,11 2 0,-16 0 0,-1 0 0,1 0 0,-1 1 0,0 0 0,1 0 0,-1 0 0,-1 1 0,1 0 0,-1 0 0,1 1 0,-1-1 0,0 1 0,-1 0 0,1 0 0,-1 1 0,6 9 0,2 5 0,-1 0 0,-1 0 0,13 38 0,-7-3 0,-3 1 0,11 98 0,-1 0 0,-17-116 0,-3 0 0,-1 60 0,0-4 0,12 57 0,-7-34 0,0 17 0,-8-35 0,2 108 0,1-194 0,0-1 0,1 1 0,1-1 0,0 0 0,0 0 0,1-1 0,1 1 0,0-1 0,0 0 0,1-1 0,1 0 0,0 0 0,15 16 0,-19-24 0,-1 1 0,1-1 0,0 0 0,0 0 0,0-1 0,0 1 0,0-1 0,0 1 0,1-1 0,-1-1 0,0 1 0,1-1 0,-1 1 0,9-2 0,-4 1 0,1-1 0,0 0 0,0 0 0,-1-1 0,16-5 0,-23 6 0,-1 0 0,1 1 0,-1-1 0,1 0 0,-1 0 0,0 0 0,1 0 0,-1 0 0,0 0 0,0 0 0,0 0 0,0-1 0,0 1 0,0 0 0,0-1 0,0 1 0,0-1 0,-1 1 0,2-3 0,-22 20 0,10-5 0,0 0 0,0 0 0,1 1 0,0 0 0,1 0 0,0 1 0,1 0 0,1 1 0,0-1 0,1 1 0,0 1 0,1-1 0,1 0 0,0 1 0,-1 19 0,1 211 0,5-132 0,1-17 0,27 171 0,47 89 0,-72-335 0,-1 0 0,0 0 0,-2 0 0,-1 0 0,-1 42 0,-2-52 0,0 1 0,0-1 0,-1 0 0,0 1 0,-1-1 0,0-1 0,-1 1 0,0-1 0,-1 1 0,0-2 0,0 1 0,-12 12 0,10-12 9,-2-1 1,1 0-1,-1-1 0,-1 0 0,1 0 1,-1-1-1,0 0 0,-1-1 0,0-1 0,0 0 1,0 0-1,-17 3 0,18-5-102,1-2 0,-1 1 1,0-1-1,0-1 0,0 0 0,1-1 0,-1 0 0,0 0 1,0-1-1,1-1 0,-1 0 0,1 0 0,0-1 1,0 0-1,-11-6 0,-7-8-6733</inkml:trace>
+</inkml:ink>
+</file>
+
+<file path=ppt/ink/ink40.xml><?xml version="1.0" encoding="utf-8"?>
+<inkml:ink xmlns:inkml="http://www.w3.org/2003/InkML">
+  <inkml:definitions>
+    <inkml:context xml:id="ctx0">
+      <inkml:inkSource xml:id="inkSrc0">
+        <inkml:traceFormat>
+          <inkml:channel name="X" type="integer" min="-2.14748E9" max="2.14748E9" units="cm"/>
+          <inkml:channel name="Y" type="integer" min="-2.14748E9" max="2.14748E9" units="cm"/>
+          <inkml:channel name="F" type="integer" max="32767" units="dev"/>
+        </inkml:traceFormat>
+        <inkml:channelProperties>
+          <inkml:channelProperty channel="X" name="resolution" value="1000" units="1/cm"/>
+          <inkml:channelProperty channel="Y" name="resolution" value="1000" units="1/cm"/>
+          <inkml:channelProperty channel="F" name="resolution" value="0" units="1/dev"/>
+        </inkml:channelProperties>
+      </inkml:inkSource>
+      <inkml:timestamp xml:id="ts0" timeString="2023-01-19T17:57:02.523"/>
+    </inkml:context>
+    <inkml:brush xml:id="br0">
+      <inkml:brushProperty name="width" value="0.2" units="cm"/>
+      <inkml:brushProperty name="height" value="0.2" units="cm"/>
+      <inkml:brushProperty name="color" value="#E71224"/>
+    </inkml:brush>
+  </inkml:definitions>
+  <inkml:trace contextRef="#ctx0" brushRef="#br0">1 1959 24575,'1'-1'0,"1"1"0,-1 0 0,1-1 0,0 1 0,-1-1 0,1 1 0,-1-1 0,1 0 0,-1 0 0,0 1 0,1-1 0,-1 0 0,0 0 0,1 0 0,-1-1 0,0 1 0,0 0 0,0 0 0,0-1 0,0 1 0,0 0 0,-1-1 0,1 1 0,0-1 0,0-1 0,3-7 0,-1 0 0,4-19 0,-4 16 0,3-14 0,2 0 0,1 0 0,14-30 0,16-35 0,-30 65 0,2 1 0,1 0 0,30-46 0,-35 60 0,0 0 0,11-25 0,-12 22 0,16-26 0,-2 8 0,19-25 0,-5 9 0,-24 34 0,0 0 0,0 1 0,14-13 0,-15 16 0,1-1 0,-2 0 0,1-1 0,-2 1 0,7-16 0,20-31 0,-12 25 0,-2-1 0,22-51 0,17-33 0,-53 106 0,2 0 0,0 1 0,0 0 0,19-19 0,-15 16 0,21-28 0,-19 22 0,1 1 0,26-27 0,-21 25 0,18-27 0,-25 34 0,1-1 0,0 1 0,24-19 0,21-22 0,-16 5 0,-20 22 0,2 1 0,0 1 0,32-25 0,-31 32 93,96-78-1551</inkml:trace>
+</inkml:ink>
+</file>
+
+<file path=ppt/ink/ink41.xml><?xml version="1.0" encoding="utf-8"?>
+<inkml:ink xmlns:inkml="http://www.w3.org/2003/InkML">
+  <inkml:definitions>
+    <inkml:context xml:id="ctx0">
+      <inkml:inkSource xml:id="inkSrc0">
+        <inkml:traceFormat>
+          <inkml:channel name="X" type="integer" min="-2.14748E9" max="2.14748E9" units="cm"/>
+          <inkml:channel name="Y" type="integer" min="-2.14748E9" max="2.14748E9" units="cm"/>
+          <inkml:channel name="F" type="integer" max="32767" units="dev"/>
+        </inkml:traceFormat>
+        <inkml:channelProperties>
+          <inkml:channelProperty channel="X" name="resolution" value="1000" units="1/cm"/>
+          <inkml:channelProperty channel="Y" name="resolution" value="1000" units="1/cm"/>
+          <inkml:channelProperty channel="F" name="resolution" value="0" units="1/dev"/>
+        </inkml:channelProperties>
+      </inkml:inkSource>
+      <inkml:timestamp xml:id="ts0" timeString="2023-01-19T17:57:03.985"/>
+    </inkml:context>
+    <inkml:brush xml:id="br0">
+      <inkml:brushProperty name="width" value="0.2" units="cm"/>
+      <inkml:brushProperty name="height" value="0.2" units="cm"/>
+      <inkml:brushProperty name="color" value="#E71224"/>
+    </inkml:brush>
+  </inkml:definitions>
+  <inkml:trace contextRef="#ctx0" brushRef="#br0">1 1 24575,'4'2'0,"1"0"0,0 1 0,-1-1 0,1 1 0,-1 0 0,0 0 0,0 1 0,0 0 0,-1-1 0,5 6 0,6 11 0,0 1 0,-2 1 0,0 0 0,11 29 0,26 77 0,-41-108 0,-1 0 0,0 0 0,-2 0 0,5 36 0,-5-11 0,-2 53 0,-3-87 0,1-1 0,0 1 0,1 0 0,0 0 0,1-1 0,0 1 0,0-1 0,1 0 0,1 0 0,-1 0 0,2-1 0,-1 1 0,13 13 0,0 0 0,-13-16 0,1 0 0,-1-1 0,11 9 0,-13-12 0,0-1 0,0 0 0,1-1 0,-1 1 0,0-1 0,1 1 0,-1-1 0,1 0 0,-1 0 0,1 0 0,6 0 0,-3-1 0,-1 0 0,0 0 0,0-1 0,0 0 0,0 0 0,0-1 0,-1 1 0,1-1 0,0 0 0,7-4 0,6-5 0,28-20 0,2-1 0,-22 16 0,-13 8 0,1-1 0,0 2 0,25-9 0,0 2 0,49-25 0,-61 26 0,90-47 0,-105 53 9,1-1 0,14-11-1,-10 6-1399</inkml:trace>
+</inkml:ink>
+</file>
+
+<file path=ppt/ink/ink42.xml><?xml version="1.0" encoding="utf-8"?>
+<inkml:ink xmlns:inkml="http://www.w3.org/2003/InkML">
+  <inkml:definitions>
+    <inkml:context xml:id="ctx0">
+      <inkml:inkSource xml:id="inkSrc0">
+        <inkml:traceFormat>
+          <inkml:channel name="X" type="integer" min="-2.14748E9" max="2.14748E9" units="cm"/>
+          <inkml:channel name="Y" type="integer" min="-2.14748E9" max="2.14748E9" units="cm"/>
+          <inkml:channel name="F" type="integer" max="32767" units="dev"/>
+        </inkml:traceFormat>
+        <inkml:channelProperties>
+          <inkml:channelProperty channel="X" name="resolution" value="1000" units="1/cm"/>
+          <inkml:channelProperty channel="Y" name="resolution" value="1000" units="1/cm"/>
+          <inkml:channelProperty channel="F" name="resolution" value="0" units="1/dev"/>
+        </inkml:channelProperties>
+      </inkml:inkSource>
+      <inkml:timestamp xml:id="ts0" timeString="2023-01-19T17:57:06.448"/>
+    </inkml:context>
+    <inkml:brush xml:id="br0">
+      <inkml:brushProperty name="width" value="0.2" units="cm"/>
+      <inkml:brushProperty name="height" value="0.2" units="cm"/>
+      <inkml:brushProperty name="color" value="#E71224"/>
+    </inkml:brush>
+  </inkml:definitions>
+  <inkml:trace contextRef="#ctx0" brushRef="#br0">0 1 24575,'0'2'0,"1"0"0,-1 0 0,1 1 0,0-1 0,-1 0 0,1 0 0,0 0 0,0 0 0,0 0 0,1 0 0,-1 0 0,0 0 0,2 1 0,25 25 0,-20-20 0,35 34 0,77 69 0,-109-102 0,-1 0 0,0 1 0,-1 0 0,0 1 0,0 0 0,-1 0 0,-1 1 0,0 0 0,8 19 0,-8-13 0,-2-1 0,0 1 0,0 0 0,-2 1 0,0-1 0,0 31 0,-2-33 0,1 0 0,1-1 0,0 1 0,7 15 0,-5-13 0,0 0 0,3 32 0,2 33 0,2 41 0,-12 301 0,-1-194 0,0-197 0,-10 49 0,3-22 0,8-56-114,-1 0 1,0 0-1,1 0 0,-2 1 0,1-1 1,0 0-1,-1-1 0,0 1 0,0 0 1,-1 0-1,-2 3 0</inkml:trace>
+</inkml:ink>
+</file>
+
+<file path=ppt/ink/ink43.xml><?xml version="1.0" encoding="utf-8"?>
+<inkml:ink xmlns:inkml="http://www.w3.org/2003/InkML">
+  <inkml:definitions>
+    <inkml:context xml:id="ctx0">
+      <inkml:inkSource xml:id="inkSrc0">
+        <inkml:traceFormat>
+          <inkml:channel name="X" type="integer" min="-2.14748E9" max="2.14748E9" units="cm"/>
+          <inkml:channel name="Y" type="integer" min="-2.14748E9" max="2.14748E9" units="cm"/>
+          <inkml:channel name="F" type="integer" max="32767" units="dev"/>
+        </inkml:traceFormat>
+        <inkml:channelProperties>
+          <inkml:channelProperty channel="X" name="resolution" value="1000" units="1/cm"/>
+          <inkml:channelProperty channel="Y" name="resolution" value="1000" units="1/cm"/>
+          <inkml:channelProperty channel="F" name="resolution" value="0" units="1/dev"/>
+        </inkml:channelProperties>
+      </inkml:inkSource>
+      <inkml:timestamp xml:id="ts0" timeString="2023-01-19T17:57:07.493"/>
+    </inkml:context>
+    <inkml:brush xml:id="br0">
+      <inkml:brushProperty name="width" value="0.2" units="cm"/>
+      <inkml:brushProperty name="height" value="0.2" units="cm"/>
+      <inkml:brushProperty name="color" value="#E71224"/>
+    </inkml:brush>
+  </inkml:definitions>
+  <inkml:trace contextRef="#ctx0" brushRef="#br0">1 1554 24575,'0'-5'0,"1"0"0,0 1 0,0-1 0,0 0 0,1 0 0,0 1 0,0-1 0,0 1 0,0 0 0,4-5 0,31-42 0,-29 41 0,26-33-976,72-69 1,101-102 975,-192 200 0,0 0 0,1 0 0,1 2 0,19-12 0,13-10 0,10-9-705,122-66 0,-123 78 705,63-30 0,98-41 0,-141 63 0,34-3-946,-62 24 663,85-40-1326,-37 22 1415,-16 6 183,125-44-85,-108 39 96,117-25 0,-95 29 0,21-2-11,9-2 65,-102 23 162,-31 8-217,1 0 0,19-8 0,149-66 2905,-162 68-7755</inkml:trace>
+</inkml:ink>
+</file>
+
+<file path=ppt/ink/ink44.xml><?xml version="1.0" encoding="utf-8"?>
+<inkml:ink xmlns:inkml="http://www.w3.org/2003/InkML">
+  <inkml:definitions>
+    <inkml:context xml:id="ctx0">
+      <inkml:inkSource xml:id="inkSrc0">
+        <inkml:traceFormat>
+          <inkml:channel name="X" type="integer" min="-2.14748E9" max="2.14748E9" units="cm"/>
+          <inkml:channel name="Y" type="integer" min="-2.14748E9" max="2.14748E9" units="cm"/>
+          <inkml:channel name="F" type="integer" max="32767" units="dev"/>
+        </inkml:traceFormat>
+        <inkml:channelProperties>
+          <inkml:channelProperty channel="X" name="resolution" value="1000" units="1/cm"/>
+          <inkml:channelProperty channel="Y" name="resolution" value="1000" units="1/cm"/>
+          <inkml:channelProperty channel="F" name="resolution" value="0" units="1/dev"/>
+        </inkml:channelProperties>
+      </inkml:inkSource>
+      <inkml:timestamp xml:id="ts0" timeString="2023-01-19T17:57:09.351"/>
+    </inkml:context>
+    <inkml:brush xml:id="br0">
+      <inkml:brushProperty name="width" value="0.2" units="cm"/>
+      <inkml:brushProperty name="height" value="0.2" units="cm"/>
+      <inkml:brushProperty name="color" value="#E71224"/>
+    </inkml:brush>
+  </inkml:definitions>
+  <inkml:trace contextRef="#ctx0" brushRef="#br0">0 0 24575,'36'12'0,"10"-6"0,1-2 0,0-3 0,48-3 0,-12 0 0,423 2 0,-492 1 0,0 1 0,0 0 0,0 1 0,-1 1 0,17 6 0,23 5 0,-50-14 0,-1-1 0,1 1 0,0 0 0,-1-1 0,1 1 0,-1 1 0,1-1 0,-1 0 0,1 1 0,-1-1 0,0 1 0,0-1 0,1 1 0,-1 0 0,0 0 0,-1 0 0,1 0 0,0 1 0,-1-1 0,1 0 0,-1 1 0,0-1 0,0 1 0,2 5 0,-2-3 0,-1 0 0,1 0 0,-1 0 0,0 0 0,-1 0 0,1 1 0,-1-1 0,0 0 0,0 0 0,-1 0 0,0 0 0,-3 7 0,-130 285 0,55-153 0,24-52 0,39-67 0,1 1 0,1 1 0,-12 31 0,-12 25-1365</inkml:trace>
 </inkml:ink>
 </file>
 
@@ -1279,7 +1448,7 @@
           <a:p>
             <a:fld id="{207C662F-A001-4EA2-B345-C237CD6465E1}" type="datetimeFigureOut">
               <a:rPr lang="en-US" smtClean="0"/>
-              <a:t>1/9/2026</a:t>
+              <a:t>2/10/2026</a:t>
             </a:fld>
             <a:endParaRPr lang="en-US"/>
           </a:p>
@@ -1679,15 +1848,7 @@
           <a:p>
             <a:r>
               <a:rPr lang="fr-FR" dirty="0"/>
-              <a:t>Bien rappeler aux étudiants ce qu’on représente en x, en y et en z à chaque fois sur les graphes de </a:t>
-            </a:r>
-            <a:r>
-              <a:rPr lang="fr-FR" dirty="0" err="1"/>
-              <a:t>loss</a:t>
-            </a:r>
-            <a:r>
-              <a:rPr lang="fr-FR" dirty="0"/>
-              <a:t> en fonction des paramètres.</a:t>
+              <a:t>On va d’ailleurs coder la dernière figure dès maintenant.</a:t>
             </a:r>
           </a:p>
         </p:txBody>
@@ -1718,7 +1879,7 @@
     </p:spTree>
     <p:extLst>
       <p:ext uri="{BB962C8B-B14F-4D97-AF65-F5344CB8AC3E}">
-        <p14:creationId xmlns:p14="http://schemas.microsoft.com/office/powerpoint/2010/main" val="733670393"/>
+        <p14:creationId xmlns:p14="http://schemas.microsoft.com/office/powerpoint/2010/main" val="1204538897"/>
       </p:ext>
     </p:extLst>
   </p:cSld>
@@ -1813,7 +1974,7 @@
     </p:spTree>
     <p:extLst>
       <p:ext uri="{BB962C8B-B14F-4D97-AF65-F5344CB8AC3E}">
-        <p14:creationId xmlns:p14="http://schemas.microsoft.com/office/powerpoint/2010/main" val="3618267343"/>
+        <p14:creationId xmlns:p14="http://schemas.microsoft.com/office/powerpoint/2010/main" val="733670393"/>
       </p:ext>
     </p:extLst>
   </p:cSld>
@@ -1867,7 +2028,18 @@
           <a:bodyPr/>
           <a:lstStyle/>
           <a:p>
-            <a:endParaRPr lang="fr-FR" dirty="0"/>
+            <a:r>
+              <a:rPr lang="fr-FR" dirty="0"/>
+              <a:t>Bien rappeler aux étudiants ce qu’on représente en x, en y et en z à chaque fois sur les graphes de </a:t>
+            </a:r>
+            <a:r>
+              <a:rPr lang="fr-FR" dirty="0" err="1"/>
+              <a:t>loss</a:t>
+            </a:r>
+            <a:r>
+              <a:rPr lang="fr-FR" dirty="0"/>
+              <a:t> en fonction des paramètres.</a:t>
+            </a:r>
           </a:p>
         </p:txBody>
       </p:sp>
@@ -1897,7 +2069,7 @@
     </p:spTree>
     <p:extLst>
       <p:ext uri="{BB962C8B-B14F-4D97-AF65-F5344CB8AC3E}">
-        <p14:creationId xmlns:p14="http://schemas.microsoft.com/office/powerpoint/2010/main" val="1420508572"/>
+        <p14:creationId xmlns:p14="http://schemas.microsoft.com/office/powerpoint/2010/main" val="3618267343"/>
       </p:ext>
     </p:extLst>
   </p:cSld>
@@ -1981,7 +2153,7 @@
     </p:spTree>
     <p:extLst>
       <p:ext uri="{BB962C8B-B14F-4D97-AF65-F5344CB8AC3E}">
-        <p14:creationId xmlns:p14="http://schemas.microsoft.com/office/powerpoint/2010/main" val="2015812420"/>
+        <p14:creationId xmlns:p14="http://schemas.microsoft.com/office/powerpoint/2010/main" val="1420508572"/>
       </p:ext>
     </p:extLst>
   </p:cSld>
@@ -2035,64 +2207,6 @@
           <a:bodyPr/>
           <a:lstStyle/>
           <a:p>
-            <a:r>
-              <a:rPr lang="en-US" dirty="0"/>
-              <a:t>The choice of neurons to be deactivated is random. All neurons are assigned a probability p which determines their activation. A new hyperparameter!! When p = 0.1, each neuron has a 1 in 10 chance of being deactivated. At each epoch, we apply this random deactivation. That is, at each pass (forward propagation) the model will learn with a different configuration of neurons, with the neurons randomly turning on and off. </a:t>
-            </a:r>
-            <a:br>
-              <a:rPr lang="en-US" dirty="0"/>
-            </a:br>
-            <a:r>
-              <a:rPr lang="en-US" dirty="0"/>
-              <a:t>This procedure effectively generates slightly different models with different neuron configurations at each iteration.</a:t>
-            </a:r>
-            <a:br>
-              <a:rPr lang="en-US" dirty="0"/>
-            </a:br>
-            <a:br>
-              <a:rPr lang="en-US" dirty="0"/>
-            </a:br>
-            <a:r>
-              <a:rPr lang="en-US" dirty="0"/>
-              <a:t>Caution: Dropout is only active during model training. During tests, each neuron remains active.</a:t>
-            </a:r>
-          </a:p>
-          <a:p>
-            <a:r>
-              <a:rPr lang="en-US" dirty="0"/>
-              <a:t>Caution2: </a:t>
-            </a:r>
-            <a:r>
-              <a:rPr lang="en-US" b="0" i="0" dirty="0">
-                <a:solidFill>
-                  <a:srgbClr val="232629"/>
-                </a:solidFill>
-                <a:effectLst/>
-                <a:latin typeface="-apple-system"/>
-              </a:rPr>
-              <a:t>Consider the neurons at the output layer. During training, each neuron usually get activations only from n neurons from the hidden layer due to dropout. Now, imagine we finished the training and remove dropout. Now activations of the output neurons will be computed based on more neurons ! This is likely to put the output neurons in unusual regime, so they will produce too large absolute values, being overexcited. To avoid this, t</a:t>
-            </a:r>
-            <a:r>
-              <a:rPr lang="en-US" dirty="0">
-                <a:effectLst/>
-                <a:latin typeface="ui-monospace"/>
-              </a:rPr>
-              <a:t>he outputs are scaled by a </a:t>
-            </a:r>
-            <a:r>
-              <a:rPr lang="en-US">
-                <a:effectLst/>
-                <a:latin typeface="ui-monospace"/>
-              </a:rPr>
-              <a:t>factor of </a:t>
-            </a:r>
-            <a:r>
-              <a:rPr lang="en-US" dirty="0">
-                <a:effectLst/>
-                <a:latin typeface="ui-monospace"/>
-              </a:rPr>
-              <a:t>1/(1-p) during training.</a:t>
-            </a:r>
             <a:endParaRPr lang="fr-FR" dirty="0"/>
           </a:p>
         </p:txBody>
@@ -2123,7 +2237,7 @@
     </p:spTree>
     <p:extLst>
       <p:ext uri="{BB962C8B-B14F-4D97-AF65-F5344CB8AC3E}">
-        <p14:creationId xmlns:p14="http://schemas.microsoft.com/office/powerpoint/2010/main" val="3595983183"/>
+        <p14:creationId xmlns:p14="http://schemas.microsoft.com/office/powerpoint/2010/main" val="2015812420"/>
       </p:ext>
     </p:extLst>
   </p:cSld>
@@ -2177,6 +2291,64 @@
           <a:bodyPr/>
           <a:lstStyle/>
           <a:p>
+            <a:r>
+              <a:rPr lang="en-US" dirty="0"/>
+              <a:t>The choice of neurons to be deactivated is random. All neurons are assigned a probability p which determines their activation. A new hyperparameter!! When p = 0.1, each neuron has a 1 in 10 chance of being deactivated. At each epoch, we apply this random deactivation. That is, at each pass (forward propagation) the model will learn with a different configuration of neurons, with the neurons randomly turning on and off. </a:t>
+            </a:r>
+            <a:br>
+              <a:rPr lang="en-US" dirty="0"/>
+            </a:br>
+            <a:r>
+              <a:rPr lang="en-US" dirty="0"/>
+              <a:t>This procedure effectively generates slightly different models with different neuron configurations at each iteration.</a:t>
+            </a:r>
+            <a:br>
+              <a:rPr lang="en-US" dirty="0"/>
+            </a:br>
+            <a:br>
+              <a:rPr lang="en-US" dirty="0"/>
+            </a:br>
+            <a:r>
+              <a:rPr lang="en-US" dirty="0"/>
+              <a:t>Caution: Dropout is only active during model training. During tests, each neuron remains active.</a:t>
+            </a:r>
+          </a:p>
+          <a:p>
+            <a:r>
+              <a:rPr lang="en-US" dirty="0"/>
+              <a:t>Caution2: </a:t>
+            </a:r>
+            <a:r>
+              <a:rPr lang="en-US" b="0" i="0" dirty="0">
+                <a:solidFill>
+                  <a:srgbClr val="232629"/>
+                </a:solidFill>
+                <a:effectLst/>
+                <a:latin typeface="-apple-system"/>
+              </a:rPr>
+              <a:t>Consider the neurons at the output layer. During training, each neuron usually get activations only from n neurons from the hidden layer due to dropout. Now, imagine we finished the training and remove dropout. Now activations of the output neurons will be computed based on more neurons ! This is likely to put the output neurons in unusual regime, so they will produce too large absolute values, being overexcited. To avoid this, t</a:t>
+            </a:r>
+            <a:r>
+              <a:rPr lang="en-US" dirty="0">
+                <a:effectLst/>
+                <a:latin typeface="ui-monospace"/>
+              </a:rPr>
+              <a:t>he outputs are scaled by a </a:t>
+            </a:r>
+            <a:r>
+              <a:rPr lang="en-US">
+                <a:effectLst/>
+                <a:latin typeface="ui-monospace"/>
+              </a:rPr>
+              <a:t>factor of </a:t>
+            </a:r>
+            <a:r>
+              <a:rPr lang="en-US" dirty="0">
+                <a:effectLst/>
+                <a:latin typeface="ui-monospace"/>
+              </a:rPr>
+              <a:t>1/(1-p) during training.</a:t>
+            </a:r>
             <a:endParaRPr lang="fr-FR" dirty="0"/>
           </a:p>
         </p:txBody>
@@ -2207,7 +2379,7 @@
     </p:spTree>
     <p:extLst>
       <p:ext uri="{BB962C8B-B14F-4D97-AF65-F5344CB8AC3E}">
-        <p14:creationId xmlns:p14="http://schemas.microsoft.com/office/powerpoint/2010/main" val="1915823295"/>
+        <p14:creationId xmlns:p14="http://schemas.microsoft.com/office/powerpoint/2010/main" val="3595983183"/>
       </p:ext>
     </p:extLst>
   </p:cSld>
@@ -2261,22 +2433,6 @@
           <a:bodyPr/>
           <a:lstStyle/>
           <a:p>
-            <a:r>
-              <a:rPr lang="fr-FR" dirty="0"/>
-              <a:t>Donner un exemple (dog cat horse </a:t>
-            </a:r>
-            <a:r>
-              <a:rPr lang="fr-FR" dirty="0" err="1"/>
-              <a:t>human</a:t>
-            </a:r>
-            <a:r>
-              <a:rPr lang="fr-FR" dirty="0"/>
-              <a:t>) et calculer la </a:t>
-            </a:r>
-            <a:r>
-              <a:rPr lang="fr-FR" dirty="0" err="1"/>
-              <a:t>loss</a:t>
-            </a:r>
             <a:endParaRPr lang="fr-FR" dirty="0"/>
           </a:p>
         </p:txBody>
@@ -2307,7 +2463,7 @@
     </p:spTree>
     <p:extLst>
       <p:ext uri="{BB962C8B-B14F-4D97-AF65-F5344CB8AC3E}">
-        <p14:creationId xmlns:p14="http://schemas.microsoft.com/office/powerpoint/2010/main" val="1383870905"/>
+        <p14:creationId xmlns:p14="http://schemas.microsoft.com/office/powerpoint/2010/main" val="1915823295"/>
       </p:ext>
     </p:extLst>
   </p:cSld>
@@ -2363,25 +2519,21 @@
           <a:p>
             <a:r>
               <a:rPr lang="fr-FR" dirty="0"/>
-              <a:t>Pourquoi y a que x_{n, y_{n}} ? Parce que, pour tous les autres le, P*(i) vaut 0 !!!</a:t>
-            </a:r>
-          </a:p>
-          <a:p>
+              <a:t>Donner un exemple (dog cat horse </a:t>
+            </a:r>
+            <a:r>
+              <a:rPr lang="fr-FR" dirty="0" err="1"/>
+              <a:t>human</a:t>
+            </a:r>
+            <a:r>
+              <a:rPr lang="fr-FR" dirty="0"/>
+              <a:t>) et calculer la </a:t>
+            </a:r>
+            <a:r>
+              <a:rPr lang="fr-FR" dirty="0" err="1"/>
+              <a:t>loss</a:t>
+            </a:r>
             <a:endParaRPr lang="fr-FR" dirty="0"/>
-          </a:p>
-          <a:p>
-            <a:r>
-              <a:rPr lang="fr-FR" dirty="0"/>
-              <a:t>Si on fait </a:t>
-            </a:r>
-            <a:r>
-              <a:rPr lang="fr-FR" dirty="0" err="1"/>
-              <a:t>mean</a:t>
-            </a:r>
-            <a:r>
-              <a:rPr lang="fr-FR" dirty="0"/>
-              <a:t>, on divise pas par N mais par les poids attention !!!!!! En pratique de toute façon, avec PyTorch, on s’en fiche … mais c’est important de savoir comment ça marche quand même.</a:t>
-            </a:r>
           </a:p>
         </p:txBody>
       </p:sp>
@@ -2411,7 +2563,7 @@
     </p:spTree>
     <p:extLst>
       <p:ext uri="{BB962C8B-B14F-4D97-AF65-F5344CB8AC3E}">
-        <p14:creationId xmlns:p14="http://schemas.microsoft.com/office/powerpoint/2010/main" val="1748699146"/>
+        <p14:creationId xmlns:p14="http://schemas.microsoft.com/office/powerpoint/2010/main" val="1383870905"/>
       </p:ext>
     </p:extLst>
   </p:cSld>
@@ -2465,7 +2617,27 @@
           <a:bodyPr/>
           <a:lstStyle/>
           <a:p>
+            <a:r>
+              <a:rPr lang="fr-FR" dirty="0"/>
+              <a:t>Pourquoi y a que x_{n, y_{n}} ? Parce que, pour tous les autres le, P*(i) vaut 0 !!!</a:t>
+            </a:r>
+          </a:p>
+          <a:p>
             <a:endParaRPr lang="fr-FR" dirty="0"/>
+          </a:p>
+          <a:p>
+            <a:r>
+              <a:rPr lang="fr-FR" dirty="0"/>
+              <a:t>Si on fait </a:t>
+            </a:r>
+            <a:r>
+              <a:rPr lang="fr-FR" dirty="0" err="1"/>
+              <a:t>mean</a:t>
+            </a:r>
+            <a:r>
+              <a:rPr lang="fr-FR" dirty="0"/>
+              <a:t>, on divise pas par N mais par les poids attention !!!!!! En pratique de toute façon, avec PyTorch, on s’en fiche … mais c’est important de savoir comment ça marche quand même.</a:t>
+            </a:r>
           </a:p>
         </p:txBody>
       </p:sp>
@@ -2495,7 +2667,7 @@
     </p:spTree>
     <p:extLst>
       <p:ext uri="{BB962C8B-B14F-4D97-AF65-F5344CB8AC3E}">
-        <p14:creationId xmlns:p14="http://schemas.microsoft.com/office/powerpoint/2010/main" val="2058295248"/>
+        <p14:creationId xmlns:p14="http://schemas.microsoft.com/office/powerpoint/2010/main" val="1748699146"/>
       </p:ext>
     </p:extLst>
   </p:cSld>
@@ -2549,64 +2721,7 @@
           <a:bodyPr/>
           <a:lstStyle/>
           <a:p>
-            <a:r>
-              <a:rPr lang="fr-FR" dirty="0" err="1"/>
-              <a:t>Why</a:t>
-            </a:r>
-            <a:r>
-              <a:rPr lang="fr-FR" dirty="0"/>
-              <a:t> log : cf. formula</a:t>
-            </a:r>
-          </a:p>
-          <a:p>
-            <a:r>
-              <a:rPr lang="fr-FR" dirty="0" err="1"/>
-              <a:t>Why</a:t>
-            </a:r>
-            <a:r>
-              <a:rPr lang="fr-FR" dirty="0"/>
-              <a:t> </a:t>
-            </a:r>
-            <a:r>
-              <a:rPr lang="fr-FR" dirty="0" err="1"/>
-              <a:t>SoftMax</a:t>
-            </a:r>
-            <a:r>
-              <a:rPr lang="fr-FR" dirty="0"/>
-              <a:t>: </a:t>
-            </a:r>
-            <a:r>
-              <a:rPr lang="fr-FR" dirty="0" err="1"/>
-              <a:t>we</a:t>
-            </a:r>
-            <a:r>
-              <a:rPr lang="fr-FR" dirty="0"/>
-              <a:t> </a:t>
-            </a:r>
-            <a:r>
-              <a:rPr lang="fr-FR" dirty="0" err="1"/>
-              <a:t>want</a:t>
-            </a:r>
-            <a:r>
-              <a:rPr lang="fr-FR" dirty="0"/>
-              <a:t> values </a:t>
-            </a:r>
-            <a:r>
-              <a:rPr lang="fr-FR" dirty="0" err="1"/>
-              <a:t>between</a:t>
-            </a:r>
-            <a:r>
-              <a:rPr lang="fr-FR" dirty="0"/>
-              <a:t> 0 and 1!!! Cf. </a:t>
-            </a:r>
-            <a:r>
-              <a:rPr lang="fr-FR" dirty="0" err="1"/>
-              <a:t>next</a:t>
-            </a:r>
-            <a:r>
-              <a:rPr lang="fr-FR" dirty="0"/>
-              <a:t> slide.</a:t>
-            </a:r>
+            <a:endParaRPr lang="fr-FR" dirty="0"/>
           </a:p>
         </p:txBody>
       </p:sp>
@@ -2636,7 +2751,7 @@
     </p:spTree>
     <p:extLst>
       <p:ext uri="{BB962C8B-B14F-4D97-AF65-F5344CB8AC3E}">
-        <p14:creationId xmlns:p14="http://schemas.microsoft.com/office/powerpoint/2010/main" val="1472243448"/>
+        <p14:creationId xmlns:p14="http://schemas.microsoft.com/office/powerpoint/2010/main" val="2058295248"/>
       </p:ext>
     </p:extLst>
   </p:cSld>
@@ -3045,7 +3160,17 @@
           <a:p>
             <a:r>
               <a:rPr lang="fr-FR" dirty="0" err="1"/>
-              <a:t>We</a:t>
+              <a:t>Why</a:t>
+            </a:r>
+            <a:r>
+              <a:rPr lang="fr-FR" dirty="0"/>
+              <a:t> log : cf. formula</a:t>
+            </a:r>
+          </a:p>
+          <a:p>
+            <a:r>
+              <a:rPr lang="fr-FR" dirty="0" err="1"/>
+              <a:t>Why</a:t>
             </a:r>
             <a:r>
               <a:rPr lang="fr-FR" dirty="0"/>
@@ -3053,7 +3178,15 @@
             </a:r>
             <a:r>
               <a:rPr lang="fr-FR" dirty="0" err="1"/>
-              <a:t>want</a:t>
+              <a:t>SoftMax</a:t>
+            </a:r>
+            <a:r>
+              <a:rPr lang="fr-FR" dirty="0"/>
+              <a:t>: </a:t>
+            </a:r>
+            <a:r>
+              <a:rPr lang="fr-FR" dirty="0" err="1"/>
+              <a:t>we</a:t>
             </a:r>
             <a:r>
               <a:rPr lang="fr-FR" dirty="0"/>
@@ -3061,60 +3194,27 @@
             </a:r>
             <a:r>
               <a:rPr lang="fr-FR" dirty="0" err="1"/>
-              <a:t>probabilities</a:t>
+              <a:t>want</a:t>
             </a:r>
             <a:r>
               <a:rPr lang="fr-FR" dirty="0"/>
-              <a:t>! And </a:t>
+              <a:t> values </a:t>
             </a:r>
             <a:r>
               <a:rPr lang="fr-FR" dirty="0" err="1"/>
-              <a:t>we</a:t>
+              <a:t>between</a:t>
             </a:r>
             <a:r>
               <a:rPr lang="fr-FR" dirty="0"/>
-              <a:t> </a:t>
+              <a:t> 0 and 1!!! Cf. </a:t>
             </a:r>
             <a:r>
               <a:rPr lang="fr-FR" dirty="0" err="1"/>
-              <a:t>don’t</a:t>
+              <a:t>next</a:t>
             </a:r>
             <a:r>
               <a:rPr lang="fr-FR" dirty="0"/>
-              <a:t> </a:t>
-            </a:r>
-            <a:r>
-              <a:rPr lang="fr-FR" dirty="0" err="1"/>
-              <a:t>want</a:t>
-            </a:r>
-            <a:r>
-              <a:rPr lang="fr-FR" dirty="0"/>
-              <a:t> </a:t>
-            </a:r>
-            <a:r>
-              <a:rPr lang="fr-FR" dirty="0" err="1"/>
-              <a:t>negative</a:t>
-            </a:r>
-            <a:r>
-              <a:rPr lang="fr-FR" dirty="0"/>
-              <a:t> values in a </a:t>
-            </a:r>
-            <a:r>
-              <a:rPr lang="fr-FR" dirty="0" err="1"/>
-              <a:t>logarithm</a:t>
-            </a:r>
-            <a:r>
-              <a:rPr lang="fr-FR" dirty="0"/>
-              <a:t> …</a:t>
-            </a:r>
-          </a:p>
-          <a:p>
-            <a:endParaRPr lang="fr-FR" dirty="0"/>
-          </a:p>
-          <a:p>
-            <a:r>
-              <a:rPr lang="fr-FR" dirty="0"/>
-              <a:t>Image source: https://www.youtube.com/watch?v=Pwgpl9mKars</a:t>
+              <a:t> slide.</a:t>
             </a:r>
           </a:p>
         </p:txBody>
@@ -3145,7 +3245,7 @@
     </p:spTree>
     <p:extLst>
       <p:ext uri="{BB962C8B-B14F-4D97-AF65-F5344CB8AC3E}">
-        <p14:creationId xmlns:p14="http://schemas.microsoft.com/office/powerpoint/2010/main" val="1484181234"/>
+        <p14:creationId xmlns:p14="http://schemas.microsoft.com/office/powerpoint/2010/main" val="1472243448"/>
       </p:ext>
     </p:extLst>
   </p:cSld>
@@ -3199,7 +3299,79 @@
           <a:bodyPr/>
           <a:lstStyle/>
           <a:p>
+            <a:r>
+              <a:rPr lang="fr-FR" dirty="0" err="1"/>
+              <a:t>We</a:t>
+            </a:r>
+            <a:r>
+              <a:rPr lang="fr-FR" dirty="0"/>
+              <a:t> </a:t>
+            </a:r>
+            <a:r>
+              <a:rPr lang="fr-FR" dirty="0" err="1"/>
+              <a:t>want</a:t>
+            </a:r>
+            <a:r>
+              <a:rPr lang="fr-FR" dirty="0"/>
+              <a:t> </a:t>
+            </a:r>
+            <a:r>
+              <a:rPr lang="fr-FR" dirty="0" err="1"/>
+              <a:t>probabilities</a:t>
+            </a:r>
+            <a:r>
+              <a:rPr lang="fr-FR" dirty="0"/>
+              <a:t>! And </a:t>
+            </a:r>
+            <a:r>
+              <a:rPr lang="fr-FR" dirty="0" err="1"/>
+              <a:t>we</a:t>
+            </a:r>
+            <a:r>
+              <a:rPr lang="fr-FR" dirty="0"/>
+              <a:t> </a:t>
+            </a:r>
+            <a:r>
+              <a:rPr lang="fr-FR" dirty="0" err="1"/>
+              <a:t>don’t</a:t>
+            </a:r>
+            <a:r>
+              <a:rPr lang="fr-FR" dirty="0"/>
+              <a:t> </a:t>
+            </a:r>
+            <a:r>
+              <a:rPr lang="fr-FR" dirty="0" err="1"/>
+              <a:t>want</a:t>
+            </a:r>
+            <a:r>
+              <a:rPr lang="fr-FR" dirty="0"/>
+              <a:t> </a:t>
+            </a:r>
+            <a:r>
+              <a:rPr lang="fr-FR" dirty="0" err="1"/>
+              <a:t>negative</a:t>
+            </a:r>
+            <a:r>
+              <a:rPr lang="fr-FR" dirty="0"/>
+              <a:t> values in a </a:t>
+            </a:r>
+            <a:r>
+              <a:rPr lang="fr-FR" dirty="0" err="1"/>
+              <a:t>logarithm</a:t>
+            </a:r>
+            <a:r>
+              <a:rPr lang="fr-FR" dirty="0"/>
+              <a:t> …</a:t>
+            </a:r>
+          </a:p>
+          <a:p>
             <a:endParaRPr lang="fr-FR" dirty="0"/>
+          </a:p>
+          <a:p>
+            <a:r>
+              <a:rPr lang="fr-FR" dirty="0"/>
+              <a:t>Image source: https://www.youtube.com/watch?v=Pwgpl9mKars</a:t>
+            </a:r>
           </a:p>
         </p:txBody>
       </p:sp>
@@ -3221,6 +3393,90 @@
             <a:fld id="{B2732108-1823-42F2-979D-D6CF9D74D210}" type="slidenum">
               <a:rPr lang="en-US" smtClean="0"/>
               <a:t>25</a:t>
+            </a:fld>
+            <a:endParaRPr lang="en-US"/>
+          </a:p>
+        </p:txBody>
+      </p:sp>
+    </p:spTree>
+    <p:extLst>
+      <p:ext uri="{BB962C8B-B14F-4D97-AF65-F5344CB8AC3E}">
+        <p14:creationId xmlns:p14="http://schemas.microsoft.com/office/powerpoint/2010/main" val="1484181234"/>
+      </p:ext>
+    </p:extLst>
+  </p:cSld>
+  <p:clrMapOvr>
+    <a:masterClrMapping/>
+  </p:clrMapOvr>
+</p:notes>
+</file>
+
+<file path=ppt/notesSlides/notesSlide22.xml><?xml version="1.0" encoding="utf-8"?>
+<p:notes xmlns:a="http://schemas.openxmlformats.org/drawingml/2006/main" xmlns:r="http://schemas.openxmlformats.org/officeDocument/2006/relationships" xmlns:p="http://schemas.openxmlformats.org/presentationml/2006/main">
+  <p:cSld>
+    <p:spTree>
+      <p:nvGrpSpPr>
+        <p:cNvPr id="1" name=""/>
+        <p:cNvGrpSpPr/>
+        <p:nvPr/>
+      </p:nvGrpSpPr>
+      <p:grpSpPr>
+        <a:xfrm>
+          <a:off x="0" y="0"/>
+          <a:ext cx="0" cy="0"/>
+          <a:chOff x="0" y="0"/>
+          <a:chExt cx="0" cy="0"/>
+        </a:xfrm>
+      </p:grpSpPr>
+      <p:sp>
+        <p:nvSpPr>
+          <p:cNvPr id="2" name="Slide Image Placeholder 1"/>
+          <p:cNvSpPr>
+            <a:spLocks noGrp="1" noRot="1" noChangeAspect="1"/>
+          </p:cNvSpPr>
+          <p:nvPr>
+            <p:ph type="sldImg"/>
+          </p:nvPr>
+        </p:nvSpPr>
+        <p:spPr/>
+      </p:sp>
+      <p:sp>
+        <p:nvSpPr>
+          <p:cNvPr id="3" name="Notes Placeholder 2"/>
+          <p:cNvSpPr>
+            <a:spLocks noGrp="1"/>
+          </p:cNvSpPr>
+          <p:nvPr>
+            <p:ph type="body" idx="1"/>
+          </p:nvPr>
+        </p:nvSpPr>
+        <p:spPr/>
+        <p:txBody>
+          <a:bodyPr/>
+          <a:lstStyle/>
+          <a:p>
+            <a:endParaRPr lang="fr-FR" dirty="0"/>
+          </a:p>
+        </p:txBody>
+      </p:sp>
+      <p:sp>
+        <p:nvSpPr>
+          <p:cNvPr id="4" name="Slide Number Placeholder 3"/>
+          <p:cNvSpPr>
+            <a:spLocks noGrp="1"/>
+          </p:cNvSpPr>
+          <p:nvPr>
+            <p:ph type="sldNum" sz="quarter" idx="5"/>
+          </p:nvPr>
+        </p:nvSpPr>
+        <p:spPr/>
+        <p:txBody>
+          <a:bodyPr/>
+          <a:lstStyle/>
+          <a:p>
+            <a:fld id="{B2732108-1823-42F2-979D-D6CF9D74D210}" type="slidenum">
+              <a:rPr lang="en-US" smtClean="0"/>
+              <a:t>26</a:t>
             </a:fld>
             <a:endParaRPr lang="en-US"/>
           </a:p>
@@ -3592,7 +3848,13 @@
   <p:cSld>
     <p:spTree>
       <p:nvGrpSpPr>
-        <p:cNvPr id="1" name=""/>
+        <p:cNvPr id="1" name="">
+          <a:extLst>
+            <a:ext uri="{FF2B5EF4-FFF2-40B4-BE49-F238E27FC236}">
+              <a16:creationId xmlns:a16="http://schemas.microsoft.com/office/drawing/2014/main" id="{690B0AB8-3B03-809D-C848-FDE977E9DDE7}"/>
+            </a:ext>
+          </a:extLst>
+        </p:cNvPr>
         <p:cNvGrpSpPr/>
         <p:nvPr/>
       </p:nvGrpSpPr>
@@ -3606,7 +3868,13 @@
       </p:grpSpPr>
       <p:sp>
         <p:nvSpPr>
-          <p:cNvPr id="2" name="Slide Image Placeholder 1"/>
+          <p:cNvPr id="2" name="Slide Image Placeholder 1">
+            <a:extLst>
+              <a:ext uri="{FF2B5EF4-FFF2-40B4-BE49-F238E27FC236}">
+                <a16:creationId xmlns:a16="http://schemas.microsoft.com/office/drawing/2014/main" id="{AAB25668-3EC1-0193-A3B3-7C35A9F17ED6}"/>
+              </a:ext>
+            </a:extLst>
+          </p:cNvPr>
           <p:cNvSpPr>
             <a:spLocks noGrp="1" noRot="1" noChangeAspect="1"/>
           </p:cNvSpPr>
@@ -3618,7 +3886,13 @@
       </p:sp>
       <p:sp>
         <p:nvSpPr>
-          <p:cNvPr id="3" name="Notes Placeholder 2"/>
+          <p:cNvPr id="3" name="Notes Placeholder 2">
+            <a:extLst>
+              <a:ext uri="{FF2B5EF4-FFF2-40B4-BE49-F238E27FC236}">
+                <a16:creationId xmlns:a16="http://schemas.microsoft.com/office/drawing/2014/main" id="{8164E9A1-FA0B-34B0-77E9-2F2FFA86C50C}"/>
+              </a:ext>
+            </a:extLst>
+          </p:cNvPr>
           <p:cNvSpPr>
             <a:spLocks noGrp="1"/>
           </p:cNvSpPr>
@@ -3631,61 +3905,19 @@
           <a:bodyPr/>
           <a:lstStyle/>
           <a:p>
-            <a:pPr marL="0" marR="0" lvl="0" indent="0" algn="l" defTabSz="914400" rtl="0" eaLnBrk="1" fontAlgn="auto" latinLnBrk="0" hangingPunct="1">
-              <a:lnSpc>
-                <a:spcPct val="100000"/>
-              </a:lnSpc>
-              <a:spcBef>
-                <a:spcPts val="0"/>
-              </a:spcBef>
-              <a:spcAft>
-                <a:spcPts val="0"/>
-              </a:spcAft>
-              <a:buClrTx/>
-              <a:buSzTx/>
-              <a:buFontTx/>
-              <a:buNone/>
-              <a:tabLst/>
-              <a:defRPr/>
-            </a:pPr>
-            <a:r>
-              <a:rPr lang="fr-FR" dirty="0"/>
-              <a:t>Bien rappeler aux étudiants ce qu’on représente en x, et en y à chaque fois sur les graphes de </a:t>
-            </a:r>
-            <a:r>
-              <a:rPr lang="fr-FR" dirty="0" err="1"/>
-              <a:t>loss</a:t>
-            </a:r>
-            <a:r>
-              <a:rPr lang="fr-FR" dirty="0"/>
-              <a:t> en fonction des paramètres.</a:t>
-            </a:r>
-          </a:p>
-          <a:p>
-            <a:pPr marL="0" marR="0" lvl="0" indent="0" algn="l" defTabSz="914400" rtl="0" eaLnBrk="1" fontAlgn="auto" latinLnBrk="0" hangingPunct="1">
-              <a:lnSpc>
-                <a:spcPct val="100000"/>
-              </a:lnSpc>
-              <a:spcBef>
-                <a:spcPts val="0"/>
-              </a:spcBef>
-              <a:spcAft>
-                <a:spcPts val="0"/>
-              </a:spcAft>
-              <a:buClrTx/>
-              <a:buSzTx/>
-              <a:buFontTx/>
-              <a:buNone/>
-              <a:tabLst/>
-              <a:defRPr/>
-            </a:pPr>
             <a:endParaRPr lang="fr-FR" dirty="0"/>
           </a:p>
         </p:txBody>
       </p:sp>
       <p:sp>
         <p:nvSpPr>
-          <p:cNvPr id="4" name="Slide Number Placeholder 3"/>
+          <p:cNvPr id="4" name="Slide Number Placeholder 3">
+            <a:extLst>
+              <a:ext uri="{FF2B5EF4-FFF2-40B4-BE49-F238E27FC236}">
+                <a16:creationId xmlns:a16="http://schemas.microsoft.com/office/drawing/2014/main" id="{D6C4753D-20BB-FD09-5C2E-1BBB6DB924DA}"/>
+              </a:ext>
+            </a:extLst>
+          </p:cNvPr>
           <p:cNvSpPr>
             <a:spLocks noGrp="1"/>
           </p:cNvSpPr>
@@ -3709,7 +3941,7 @@
     </p:spTree>
     <p:extLst>
       <p:ext uri="{BB962C8B-B14F-4D97-AF65-F5344CB8AC3E}">
-        <p14:creationId xmlns:p14="http://schemas.microsoft.com/office/powerpoint/2010/main" val="2111824487"/>
+        <p14:creationId xmlns:p14="http://schemas.microsoft.com/office/powerpoint/2010/main" val="3937148258"/>
       </p:ext>
     </p:extLst>
   </p:cSld>
@@ -3794,29 +4026,24 @@
             </a:r>
           </a:p>
           <a:p>
+            <a:pPr marL="0" marR="0" lvl="0" indent="0" algn="l" defTabSz="914400" rtl="0" eaLnBrk="1" fontAlgn="auto" latinLnBrk="0" hangingPunct="1">
+              <a:lnSpc>
+                <a:spcPct val="100000"/>
+              </a:lnSpc>
+              <a:spcBef>
+                <a:spcPts val="0"/>
+              </a:spcBef>
+              <a:spcAft>
+                <a:spcPts val="0"/>
+              </a:spcAft>
+              <a:buClrTx/>
+              <a:buSzTx/>
+              <a:buFontTx/>
+              <a:buNone/>
+              <a:tabLst/>
+              <a:defRPr/>
+            </a:pPr>
             <a:endParaRPr lang="fr-FR" dirty="0"/>
-          </a:p>
-          <a:p>
-            <a:r>
-              <a:rPr lang="fr-FR" dirty="0"/>
-              <a:t>On veut vite arriver à côté du trou (donc le </a:t>
-            </a:r>
-            <a:r>
-              <a:rPr lang="fr-FR" dirty="0" err="1"/>
-              <a:t>learning</a:t>
-            </a:r>
-            <a:r>
-              <a:rPr lang="fr-FR" dirty="0"/>
-              <a:t> rate doit être élevé au début) puis après on veut diminuer le </a:t>
-            </a:r>
-            <a:r>
-              <a:rPr lang="fr-FR" dirty="0" err="1"/>
-              <a:t>learning</a:t>
-            </a:r>
-            <a:r>
-              <a:rPr lang="fr-FR" dirty="0"/>
-              <a:t> rate sinon il y a un risque qu’on oscille juste de part et d’autre du trou.</a:t>
-            </a:r>
           </a:p>
         </p:txBody>
       </p:sp>
@@ -3846,7 +4073,7 @@
     </p:spTree>
     <p:extLst>
       <p:ext uri="{BB962C8B-B14F-4D97-AF65-F5344CB8AC3E}">
-        <p14:creationId xmlns:p14="http://schemas.microsoft.com/office/powerpoint/2010/main" val="86369302"/>
+        <p14:creationId xmlns:p14="http://schemas.microsoft.com/office/powerpoint/2010/main" val="2111824487"/>
       </p:ext>
     </p:extLst>
   </p:cSld>
@@ -3900,17 +4127,43 @@
           <a:bodyPr/>
           <a:lstStyle/>
           <a:p>
+            <a:pPr marL="0" marR="0" lvl="0" indent="0" algn="l" defTabSz="914400" rtl="0" eaLnBrk="1" fontAlgn="auto" latinLnBrk="0" hangingPunct="1">
+              <a:lnSpc>
+                <a:spcPct val="100000"/>
+              </a:lnSpc>
+              <a:spcBef>
+                <a:spcPts val="0"/>
+              </a:spcBef>
+              <a:spcAft>
+                <a:spcPts val="0"/>
+              </a:spcAft>
+              <a:buClrTx/>
+              <a:buSzTx/>
+              <a:buFontTx/>
+              <a:buNone/>
+              <a:tabLst/>
+              <a:defRPr/>
+            </a:pPr>
             <a:r>
               <a:rPr lang="fr-FR" dirty="0"/>
-              <a:t>Pareil, y a tout type de façons (parfois un peu perchés) de </a:t>
+              <a:t>Bien rappeler aux étudiants ce qu’on représente en x, et en y à chaque fois sur les graphes de </a:t>
             </a:r>
             <a:r>
               <a:rPr lang="fr-FR" dirty="0" err="1"/>
-              <a:t>scheduler</a:t>
+              <a:t>loss</a:t>
             </a:r>
             <a:r>
               <a:rPr lang="fr-FR" dirty="0"/>
-              <a:t> le </a:t>
+              <a:t> en fonction des paramètres.</a:t>
+            </a:r>
+          </a:p>
+          <a:p>
+            <a:endParaRPr lang="fr-FR" dirty="0"/>
+          </a:p>
+          <a:p>
+            <a:r>
+              <a:rPr lang="fr-FR" dirty="0"/>
+              <a:t>On veut vite arriver à côté du trou (donc le </a:t>
             </a:r>
             <a:r>
               <a:rPr lang="fr-FR" dirty="0" err="1"/>
@@ -3918,15 +4171,15 @@
             </a:r>
             <a:r>
               <a:rPr lang="fr-FR" dirty="0"/>
-              <a:t> rate. Le choix de quel </a:t>
+              <a:t> rate doit être élevé au début) puis après on veut diminuer le </a:t>
             </a:r>
             <a:r>
               <a:rPr lang="fr-FR" dirty="0" err="1"/>
-              <a:t>scheduling</a:t>
+              <a:t>learning</a:t>
             </a:r>
             <a:r>
               <a:rPr lang="fr-FR" dirty="0"/>
-              <a:t> est en lui-même un hyperparamètre.</a:t>
+              <a:t> rate sinon il y a un risque qu’on oscille juste de part et d’autre du trou.</a:t>
             </a:r>
           </a:p>
         </p:txBody>
@@ -3957,7 +4210,7 @@
     </p:spTree>
     <p:extLst>
       <p:ext uri="{BB962C8B-B14F-4D97-AF65-F5344CB8AC3E}">
-        <p14:creationId xmlns:p14="http://schemas.microsoft.com/office/powerpoint/2010/main" val="2034432695"/>
+        <p14:creationId xmlns:p14="http://schemas.microsoft.com/office/powerpoint/2010/main" val="86369302"/>
       </p:ext>
     </p:extLst>
   </p:cSld>
@@ -4013,7 +4266,31 @@
           <a:p>
             <a:r>
               <a:rPr lang="fr-FR" dirty="0"/>
-              <a:t>On va d’ailleurs coder la dernière figure dès maintenant.</a:t>
+              <a:t>Pareil, y a tout type de façons (parfois un peu perchés) de </a:t>
+            </a:r>
+            <a:r>
+              <a:rPr lang="fr-FR" dirty="0" err="1"/>
+              <a:t>scheduler</a:t>
+            </a:r>
+            <a:r>
+              <a:rPr lang="fr-FR" dirty="0"/>
+              <a:t> le </a:t>
+            </a:r>
+            <a:r>
+              <a:rPr lang="fr-FR" dirty="0" err="1"/>
+              <a:t>learning</a:t>
+            </a:r>
+            <a:r>
+              <a:rPr lang="fr-FR" dirty="0"/>
+              <a:t> rate. Le choix de quel </a:t>
+            </a:r>
+            <a:r>
+              <a:rPr lang="fr-FR" dirty="0" err="1"/>
+              <a:t>scheduling</a:t>
+            </a:r>
+            <a:r>
+              <a:rPr lang="fr-FR" dirty="0"/>
+              <a:t> est en lui-même un hyperparamètre.</a:t>
             </a:r>
           </a:p>
         </p:txBody>
@@ -4044,7 +4321,7 @@
     </p:spTree>
     <p:extLst>
       <p:ext uri="{BB962C8B-B14F-4D97-AF65-F5344CB8AC3E}">
-        <p14:creationId xmlns:p14="http://schemas.microsoft.com/office/powerpoint/2010/main" val="1204538897"/>
+        <p14:creationId xmlns:p14="http://schemas.microsoft.com/office/powerpoint/2010/main" val="2034432695"/>
       </p:ext>
     </p:extLst>
   </p:cSld>
@@ -4201,7 +4478,7 @@
           <a:p>
             <a:fld id="{4F06803B-D602-4C3D-AD5C-468F46C70933}" type="datetimeFigureOut">
               <a:rPr lang="en-US" smtClean="0"/>
-              <a:t>1/9/2026</a:t>
+              <a:t>2/10/2026</a:t>
             </a:fld>
             <a:endParaRPr lang="en-US"/>
           </a:p>
@@ -4399,7 +4676,7 @@
           <a:p>
             <a:fld id="{4F06803B-D602-4C3D-AD5C-468F46C70933}" type="datetimeFigureOut">
               <a:rPr lang="en-US" smtClean="0"/>
-              <a:t>1/9/2026</a:t>
+              <a:t>2/10/2026</a:t>
             </a:fld>
             <a:endParaRPr lang="en-US"/>
           </a:p>
@@ -4607,7 +4884,7 @@
           <a:p>
             <a:fld id="{4F06803B-D602-4C3D-AD5C-468F46C70933}" type="datetimeFigureOut">
               <a:rPr lang="en-US" smtClean="0"/>
-              <a:t>1/9/2026</a:t>
+              <a:t>2/10/2026</a:t>
             </a:fld>
             <a:endParaRPr lang="en-US"/>
           </a:p>
@@ -4805,7 +5082,7 @@
           <a:p>
             <a:fld id="{4F06803B-D602-4C3D-AD5C-468F46C70933}" type="datetimeFigureOut">
               <a:rPr lang="en-US" smtClean="0"/>
-              <a:t>1/9/2026</a:t>
+              <a:t>2/10/2026</a:t>
             </a:fld>
             <a:endParaRPr lang="en-US"/>
           </a:p>
@@ -5080,7 +5357,7 @@
           <a:p>
             <a:fld id="{4F06803B-D602-4C3D-AD5C-468F46C70933}" type="datetimeFigureOut">
               <a:rPr lang="en-US" smtClean="0"/>
-              <a:t>1/9/2026</a:t>
+              <a:t>2/10/2026</a:t>
             </a:fld>
             <a:endParaRPr lang="en-US"/>
           </a:p>
@@ -5345,7 +5622,7 @@
           <a:p>
             <a:fld id="{4F06803B-D602-4C3D-AD5C-468F46C70933}" type="datetimeFigureOut">
               <a:rPr lang="en-US" smtClean="0"/>
-              <a:t>1/9/2026</a:t>
+              <a:t>2/10/2026</a:t>
             </a:fld>
             <a:endParaRPr lang="en-US"/>
           </a:p>
@@ -5757,7 +6034,7 @@
           <a:p>
             <a:fld id="{4F06803B-D602-4C3D-AD5C-468F46C70933}" type="datetimeFigureOut">
               <a:rPr lang="en-US" smtClean="0"/>
-              <a:t>1/9/2026</a:t>
+              <a:t>2/10/2026</a:t>
             </a:fld>
             <a:endParaRPr lang="en-US"/>
           </a:p>
@@ -5898,7 +6175,7 @@
           <a:p>
             <a:fld id="{4F06803B-D602-4C3D-AD5C-468F46C70933}" type="datetimeFigureOut">
               <a:rPr lang="en-US" smtClean="0"/>
-              <a:t>1/9/2026</a:t>
+              <a:t>2/10/2026</a:t>
             </a:fld>
             <a:endParaRPr lang="en-US"/>
           </a:p>
@@ -6011,7 +6288,7 @@
           <a:p>
             <a:fld id="{4F06803B-D602-4C3D-AD5C-468F46C70933}" type="datetimeFigureOut">
               <a:rPr lang="en-US" smtClean="0"/>
-              <a:t>1/9/2026</a:t>
+              <a:t>2/10/2026</a:t>
             </a:fld>
             <a:endParaRPr lang="en-US"/>
           </a:p>
@@ -6322,7 +6599,7 @@
           <a:p>
             <a:fld id="{4F06803B-D602-4C3D-AD5C-468F46C70933}" type="datetimeFigureOut">
               <a:rPr lang="en-US" smtClean="0"/>
-              <a:t>1/9/2026</a:t>
+              <a:t>2/10/2026</a:t>
             </a:fld>
             <a:endParaRPr lang="en-US"/>
           </a:p>
@@ -6610,7 +6887,7 @@
           <a:p>
             <a:fld id="{4F06803B-D602-4C3D-AD5C-468F46C70933}" type="datetimeFigureOut">
               <a:rPr lang="en-US" smtClean="0"/>
-              <a:t>1/9/2026</a:t>
+              <a:t>2/10/2026</a:t>
             </a:fld>
             <a:endParaRPr lang="en-US"/>
           </a:p>
@@ -6851,7 +7128,7 @@
           <a:p>
             <a:fld id="{4F06803B-D602-4C3D-AD5C-468F46C70933}" type="datetimeFigureOut">
               <a:rPr lang="en-US" smtClean="0"/>
-              <a:t>1/9/2026</a:t>
+              <a:t>2/10/2026</a:t>
             </a:fld>
             <a:endParaRPr lang="en-US"/>
           </a:p>
@@ -7362,6 +7639,553 @@
   <p:cSld>
     <p:spTree>
       <p:nvGrpSpPr>
+        <p:cNvPr id="1" name="">
+          <a:extLst>
+            <a:ext uri="{FF2B5EF4-FFF2-40B4-BE49-F238E27FC236}">
+              <a16:creationId xmlns:a16="http://schemas.microsoft.com/office/drawing/2014/main" id="{17B7E030-D672-D069-8CC0-B4A856544D2E}"/>
+            </a:ext>
+          </a:extLst>
+        </p:cNvPr>
+        <p:cNvGrpSpPr/>
+        <p:nvPr/>
+      </p:nvGrpSpPr>
+      <p:grpSpPr>
+        <a:xfrm>
+          <a:off x="0" y="0"/>
+          <a:ext cx="0" cy="0"/>
+          <a:chOff x="0" y="0"/>
+          <a:chExt cx="0" cy="0"/>
+        </a:xfrm>
+      </p:grpSpPr>
+      <p:sp>
+        <p:nvSpPr>
+          <p:cNvPr id="5" name="Title 4">
+            <a:extLst>
+              <a:ext uri="{FF2B5EF4-FFF2-40B4-BE49-F238E27FC236}">
+                <a16:creationId xmlns:a16="http://schemas.microsoft.com/office/drawing/2014/main" id="{0D2F9CFE-6FE9-EE93-655D-0C0BE040E662}"/>
+              </a:ext>
+            </a:extLst>
+          </p:cNvPr>
+          <p:cNvSpPr>
+            <a:spLocks noGrp="1"/>
+          </p:cNvSpPr>
+          <p:nvPr>
+            <p:ph type="title"/>
+          </p:nvPr>
+        </p:nvSpPr>
+        <p:spPr/>
+        <p:txBody>
+          <a:bodyPr/>
+          <a:lstStyle/>
+          <a:p>
+            <a:r>
+              <a:rPr lang="en-US" dirty="0"/>
+              <a:t>Learning rate per parameter</a:t>
+            </a:r>
+          </a:p>
+        </p:txBody>
+      </p:sp>
+      <p:pic>
+        <p:nvPicPr>
+          <p:cNvPr id="7" name="Picture 6">
+            <a:extLst>
+              <a:ext uri="{FF2B5EF4-FFF2-40B4-BE49-F238E27FC236}">
+                <a16:creationId xmlns:a16="http://schemas.microsoft.com/office/drawing/2014/main" id="{31B2BC52-4EB1-FAA8-86F3-E4E86E7EA0B2}"/>
+              </a:ext>
+            </a:extLst>
+          </p:cNvPr>
+          <p:cNvPicPr>
+            <a:picLocks noChangeAspect="1"/>
+          </p:cNvPicPr>
+          <p:nvPr/>
+        </p:nvPicPr>
+        <p:blipFill>
+          <a:blip r:embed="rId3"/>
+          <a:srcRect t="7338"/>
+          <a:stretch>
+            <a:fillRect/>
+          </a:stretch>
+        </p:blipFill>
+        <p:spPr>
+          <a:xfrm>
+            <a:off x="4194077" y="1360628"/>
+            <a:ext cx="3803845" cy="5219395"/>
+          </a:xfrm>
+          <a:prstGeom prst="rect">
+            <a:avLst/>
+          </a:prstGeom>
+        </p:spPr>
+      </p:pic>
+      <p:sp>
+        <p:nvSpPr>
+          <p:cNvPr id="8" name="TextBox 7">
+            <a:extLst>
+              <a:ext uri="{FF2B5EF4-FFF2-40B4-BE49-F238E27FC236}">
+                <a16:creationId xmlns:a16="http://schemas.microsoft.com/office/drawing/2014/main" id="{60CA4306-288E-848D-C42D-923EF5FD5B86}"/>
+              </a:ext>
+            </a:extLst>
+          </p:cNvPr>
+          <p:cNvSpPr txBox="1"/>
+          <p:nvPr/>
+        </p:nvSpPr>
+        <p:spPr>
+          <a:xfrm>
+            <a:off x="8095515" y="2320656"/>
+            <a:ext cx="3998976" cy="1477328"/>
+          </a:xfrm>
+          <a:prstGeom prst="rect">
+            <a:avLst/>
+          </a:prstGeom>
+          <a:noFill/>
+        </p:spPr>
+        <p:txBody>
+          <a:bodyPr wrap="square" rtlCol="0">
+            <a:spAutoFit/>
+          </a:bodyPr>
+          <a:lstStyle/>
+          <a:p>
+            <a:r>
+              <a:rPr lang="en-GB" dirty="0"/>
+              <a:t>Weight Decay (almost the same as L2</a:t>
+            </a:r>
+          </a:p>
+          <a:p>
+            <a:r>
+              <a:rPr lang="en-GB" dirty="0"/>
+              <a:t>regularization, see </a:t>
+            </a:r>
+            <a:r>
+              <a:rPr lang="en-GB" dirty="0">
+                <a:hlinkClick r:id="rId4"/>
+              </a:rPr>
+              <a:t>https://www.johntrimble.com/posts/weight-decay-is-not-l2-regularization/</a:t>
+            </a:r>
+            <a:r>
+              <a:rPr lang="en-GB" dirty="0"/>
+              <a:t> for the differences)</a:t>
+            </a:r>
+          </a:p>
+        </p:txBody>
+      </p:sp>
+      <p:grpSp>
+        <p:nvGrpSpPr>
+          <p:cNvPr id="25" name="Group 24">
+            <a:extLst>
+              <a:ext uri="{FF2B5EF4-FFF2-40B4-BE49-F238E27FC236}">
+                <a16:creationId xmlns:a16="http://schemas.microsoft.com/office/drawing/2014/main" id="{46653035-BC1B-D744-3E73-204F233B7CC9}"/>
+              </a:ext>
+            </a:extLst>
+          </p:cNvPr>
+          <p:cNvGrpSpPr/>
+          <p:nvPr/>
+        </p:nvGrpSpPr>
+        <p:grpSpPr>
+          <a:xfrm>
+            <a:off x="6802000" y="2757640"/>
+            <a:ext cx="1174320" cy="533880"/>
+            <a:chOff x="6802000" y="2757640"/>
+            <a:chExt cx="1174320" cy="533880"/>
+          </a:xfrm>
+        </p:grpSpPr>
+        <mc:AlternateContent xmlns:mc="http://schemas.openxmlformats.org/markup-compatibility/2006" xmlns:p14="http://schemas.microsoft.com/office/powerpoint/2010/main">
+          <mc:Choice Requires="p14">
+            <p:contentPart p14:bwMode="auto" r:id="rId5">
+              <p14:nvContentPartPr>
+                <p14:cNvPr id="22" name="Ink 21">
+                  <a:extLst>
+                    <a:ext uri="{FF2B5EF4-FFF2-40B4-BE49-F238E27FC236}">
+                      <a16:creationId xmlns:a16="http://schemas.microsoft.com/office/drawing/2014/main" id="{8302ABCC-BA42-262B-0038-CCD7B2B6DA22}"/>
+                    </a:ext>
+                  </a:extLst>
+                </p14:cNvPr>
+                <p14:cNvContentPartPr/>
+                <p14:nvPr/>
+              </p14:nvContentPartPr>
+              <p14:xfrm>
+                <a:off x="6802000" y="2757640"/>
+                <a:ext cx="100800" cy="533880"/>
+              </p14:xfrm>
+            </p:contentPart>
+          </mc:Choice>
+          <mc:Fallback xmlns="">
+            <p:pic>
+              <p:nvPicPr>
+                <p:cNvPr id="22" name="Ink 21">
+                  <a:extLst>
+                    <a:ext uri="{FF2B5EF4-FFF2-40B4-BE49-F238E27FC236}">
+                      <a16:creationId xmlns:a16="http://schemas.microsoft.com/office/drawing/2014/main" id="{2D6EC34F-6010-84C6-D8C1-4818A71C321F}"/>
+                    </a:ext>
+                  </a:extLst>
+                </p:cNvPr>
+                <p:cNvPicPr/>
+                <p:nvPr/>
+              </p:nvPicPr>
+              <p:blipFill>
+                <a:blip r:embed="rId11"/>
+                <a:stretch>
+                  <a:fillRect/>
+                </a:stretch>
+              </p:blipFill>
+              <p:spPr>
+                <a:xfrm>
+                  <a:off x="6795880" y="2751520"/>
+                  <a:ext cx="113040" cy="546120"/>
+                </a:xfrm>
+                <a:prstGeom prst="rect">
+                  <a:avLst/>
+                </a:prstGeom>
+              </p:spPr>
+            </p:pic>
+          </mc:Fallback>
+        </mc:AlternateContent>
+        <mc:AlternateContent xmlns:mc="http://schemas.openxmlformats.org/markup-compatibility/2006" xmlns:p14="http://schemas.microsoft.com/office/powerpoint/2010/main">
+          <mc:Choice Requires="p14">
+            <p:contentPart p14:bwMode="auto" r:id="rId12">
+              <p14:nvContentPartPr>
+                <p14:cNvPr id="23" name="Ink 22">
+                  <a:extLst>
+                    <a:ext uri="{FF2B5EF4-FFF2-40B4-BE49-F238E27FC236}">
+                      <a16:creationId xmlns:a16="http://schemas.microsoft.com/office/drawing/2014/main" id="{AC13724E-779C-83EB-6F5E-B05560713CD0}"/>
+                    </a:ext>
+                  </a:extLst>
+                </p14:cNvPr>
+                <p14:cNvContentPartPr/>
+                <p14:nvPr/>
+              </p14:nvContentPartPr>
+              <p14:xfrm>
+                <a:off x="6929440" y="3030520"/>
+                <a:ext cx="1008360" cy="28800"/>
+              </p14:xfrm>
+            </p:contentPart>
+          </mc:Choice>
+          <mc:Fallback xmlns="">
+            <p:pic>
+              <p:nvPicPr>
+                <p:cNvPr id="23" name="Ink 22">
+                  <a:extLst>
+                    <a:ext uri="{FF2B5EF4-FFF2-40B4-BE49-F238E27FC236}">
+                      <a16:creationId xmlns:a16="http://schemas.microsoft.com/office/drawing/2014/main" id="{639C8D92-0879-DE2D-385A-1BF00DA6DA9B}"/>
+                    </a:ext>
+                  </a:extLst>
+                </p:cNvPr>
+                <p:cNvPicPr/>
+                <p:nvPr/>
+              </p:nvPicPr>
+              <p:blipFill>
+                <a:blip r:embed="rId13"/>
+                <a:stretch>
+                  <a:fillRect/>
+                </a:stretch>
+              </p:blipFill>
+              <p:spPr>
+                <a:xfrm>
+                  <a:off x="6923320" y="3024400"/>
+                  <a:ext cx="1020600" cy="41040"/>
+                </a:xfrm>
+                <a:prstGeom prst="rect">
+                  <a:avLst/>
+                </a:prstGeom>
+              </p:spPr>
+            </p:pic>
+          </mc:Fallback>
+        </mc:AlternateContent>
+        <mc:AlternateContent xmlns:mc="http://schemas.openxmlformats.org/markup-compatibility/2006" xmlns:p14="http://schemas.microsoft.com/office/powerpoint/2010/main">
+          <mc:Choice Requires="p14">
+            <p:contentPart p14:bwMode="auto" r:id="rId14">
+              <p14:nvContentPartPr>
+                <p14:cNvPr id="24" name="Ink 23">
+                  <a:extLst>
+                    <a:ext uri="{FF2B5EF4-FFF2-40B4-BE49-F238E27FC236}">
+                      <a16:creationId xmlns:a16="http://schemas.microsoft.com/office/drawing/2014/main" id="{5FD3C59C-5001-A262-7814-F41DCB12F8CF}"/>
+                    </a:ext>
+                  </a:extLst>
+                </p14:cNvPr>
+                <p14:cNvContentPartPr/>
+                <p14:nvPr/>
+              </p14:nvContentPartPr>
+              <p14:xfrm>
+                <a:off x="7858600" y="2971480"/>
+                <a:ext cx="117720" cy="122040"/>
+              </p14:xfrm>
+            </p:contentPart>
+          </mc:Choice>
+          <mc:Fallback xmlns="">
+            <p:pic>
+              <p:nvPicPr>
+                <p:cNvPr id="24" name="Ink 23">
+                  <a:extLst>
+                    <a:ext uri="{FF2B5EF4-FFF2-40B4-BE49-F238E27FC236}">
+                      <a16:creationId xmlns:a16="http://schemas.microsoft.com/office/drawing/2014/main" id="{4937ACB2-4FE0-0DFA-8E66-88400B7FCD25}"/>
+                    </a:ext>
+                  </a:extLst>
+                </p:cNvPr>
+                <p:cNvPicPr/>
+                <p:nvPr/>
+              </p:nvPicPr>
+              <p:blipFill>
+                <a:blip r:embed="rId15"/>
+                <a:stretch>
+                  <a:fillRect/>
+                </a:stretch>
+              </p:blipFill>
+              <p:spPr>
+                <a:xfrm>
+                  <a:off x="7852480" y="2965360"/>
+                  <a:ext cx="129960" cy="134280"/>
+                </a:xfrm>
+                <a:prstGeom prst="rect">
+                  <a:avLst/>
+                </a:prstGeom>
+              </p:spPr>
+            </p:pic>
+          </mc:Fallback>
+        </mc:AlternateContent>
+      </p:grpSp>
+      <p:sp>
+        <p:nvSpPr>
+          <p:cNvPr id="2" name="TextBox 1">
+            <a:extLst>
+              <a:ext uri="{FF2B5EF4-FFF2-40B4-BE49-F238E27FC236}">
+                <a16:creationId xmlns:a16="http://schemas.microsoft.com/office/drawing/2014/main" id="{3C204338-8638-DD6A-5DDF-0D06EAC34245}"/>
+              </a:ext>
+            </a:extLst>
+          </p:cNvPr>
+          <p:cNvSpPr txBox="1"/>
+          <p:nvPr/>
+        </p:nvSpPr>
+        <p:spPr>
+          <a:xfrm>
+            <a:off x="9004397" y="4799072"/>
+            <a:ext cx="2055243" cy="646331"/>
+          </a:xfrm>
+          <a:prstGeom prst="rect">
+            <a:avLst/>
+          </a:prstGeom>
+          <a:noFill/>
+        </p:spPr>
+        <p:txBody>
+          <a:bodyPr wrap="none" rtlCol="0">
+            <a:spAutoFit/>
+          </a:bodyPr>
+          <a:lstStyle/>
+          <a:p>
+            <a:r>
+              <a:rPr lang="en-GB" dirty="0"/>
+              <a:t>Bias correction stuff</a:t>
+            </a:r>
+          </a:p>
+          <a:p>
+            <a:r>
+              <a:rPr lang="en-GB" dirty="0"/>
+              <a:t>(Statistics 101)</a:t>
+            </a:r>
+          </a:p>
+        </p:txBody>
+      </p:sp>
+      <p:grpSp>
+        <p:nvGrpSpPr>
+          <p:cNvPr id="3" name="Group 2">
+            <a:extLst>
+              <a:ext uri="{FF2B5EF4-FFF2-40B4-BE49-F238E27FC236}">
+                <a16:creationId xmlns:a16="http://schemas.microsoft.com/office/drawing/2014/main" id="{A4571C0F-E7E1-A496-8D02-AA16396F38D4}"/>
+              </a:ext>
+            </a:extLst>
+          </p:cNvPr>
+          <p:cNvGrpSpPr/>
+          <p:nvPr/>
+        </p:nvGrpSpPr>
+        <p:grpSpPr>
+          <a:xfrm>
+            <a:off x="7107964" y="4230818"/>
+            <a:ext cx="1742870" cy="1577537"/>
+            <a:chOff x="6802000" y="2757640"/>
+            <a:chExt cx="1174320" cy="533880"/>
+          </a:xfrm>
+        </p:grpSpPr>
+        <mc:AlternateContent xmlns:mc="http://schemas.openxmlformats.org/markup-compatibility/2006" xmlns:p14="http://schemas.microsoft.com/office/powerpoint/2010/main">
+          <mc:Choice Requires="p14">
+            <p:contentPart p14:bwMode="auto" r:id="rId16">
+              <p14:nvContentPartPr>
+                <p14:cNvPr id="4" name="Ink 3">
+                  <a:extLst>
+                    <a:ext uri="{FF2B5EF4-FFF2-40B4-BE49-F238E27FC236}">
+                      <a16:creationId xmlns:a16="http://schemas.microsoft.com/office/drawing/2014/main" id="{0C0FF3E4-749A-F7DD-42F0-AE4FD6820135}"/>
+                    </a:ext>
+                  </a:extLst>
+                </p14:cNvPr>
+                <p14:cNvContentPartPr/>
+                <p14:nvPr/>
+              </p14:nvContentPartPr>
+              <p14:xfrm>
+                <a:off x="6802000" y="2757640"/>
+                <a:ext cx="100800" cy="533880"/>
+              </p14:xfrm>
+            </p:contentPart>
+          </mc:Choice>
+          <mc:Fallback xmlns="">
+            <p:pic>
+              <p:nvPicPr>
+                <p:cNvPr id="22" name="Ink 21">
+                  <a:extLst>
+                    <a:ext uri="{FF2B5EF4-FFF2-40B4-BE49-F238E27FC236}">
+                      <a16:creationId xmlns:a16="http://schemas.microsoft.com/office/drawing/2014/main" id="{2D6EC34F-6010-84C6-D8C1-4818A71C321F}"/>
+                    </a:ext>
+                  </a:extLst>
+                </p:cNvPr>
+                <p:cNvPicPr/>
+                <p:nvPr/>
+              </p:nvPicPr>
+              <p:blipFill>
+                <a:blip r:embed="rId11"/>
+                <a:stretch>
+                  <a:fillRect/>
+                </a:stretch>
+              </p:blipFill>
+              <p:spPr>
+                <a:xfrm>
+                  <a:off x="6795880" y="2751520"/>
+                  <a:ext cx="113040" cy="546120"/>
+                </a:xfrm>
+                <a:prstGeom prst="rect">
+                  <a:avLst/>
+                </a:prstGeom>
+              </p:spPr>
+            </p:pic>
+          </mc:Fallback>
+        </mc:AlternateContent>
+        <mc:AlternateContent xmlns:mc="http://schemas.openxmlformats.org/markup-compatibility/2006" xmlns:p14="http://schemas.microsoft.com/office/powerpoint/2010/main">
+          <mc:Choice Requires="p14">
+            <p:contentPart p14:bwMode="auto" r:id="rId17">
+              <p14:nvContentPartPr>
+                <p14:cNvPr id="6" name="Ink 5">
+                  <a:extLst>
+                    <a:ext uri="{FF2B5EF4-FFF2-40B4-BE49-F238E27FC236}">
+                      <a16:creationId xmlns:a16="http://schemas.microsoft.com/office/drawing/2014/main" id="{94E7711A-BC14-48A4-A803-74DCD86C60EC}"/>
+                    </a:ext>
+                  </a:extLst>
+                </p14:cNvPr>
+                <p14:cNvContentPartPr/>
+                <p14:nvPr/>
+              </p14:nvContentPartPr>
+              <p14:xfrm>
+                <a:off x="6929440" y="3030520"/>
+                <a:ext cx="1008360" cy="28800"/>
+              </p14:xfrm>
+            </p:contentPart>
+          </mc:Choice>
+          <mc:Fallback xmlns="">
+            <p:pic>
+              <p:nvPicPr>
+                <p:cNvPr id="23" name="Ink 22">
+                  <a:extLst>
+                    <a:ext uri="{FF2B5EF4-FFF2-40B4-BE49-F238E27FC236}">
+                      <a16:creationId xmlns:a16="http://schemas.microsoft.com/office/drawing/2014/main" id="{639C8D92-0879-DE2D-385A-1BF00DA6DA9B}"/>
+                    </a:ext>
+                  </a:extLst>
+                </p:cNvPr>
+                <p:cNvPicPr/>
+                <p:nvPr/>
+              </p:nvPicPr>
+              <p:blipFill>
+                <a:blip r:embed="rId13"/>
+                <a:stretch>
+                  <a:fillRect/>
+                </a:stretch>
+              </p:blipFill>
+              <p:spPr>
+                <a:xfrm>
+                  <a:off x="6923320" y="3024400"/>
+                  <a:ext cx="1020600" cy="41040"/>
+                </a:xfrm>
+                <a:prstGeom prst="rect">
+                  <a:avLst/>
+                </a:prstGeom>
+              </p:spPr>
+            </p:pic>
+          </mc:Fallback>
+        </mc:AlternateContent>
+        <mc:AlternateContent xmlns:mc="http://schemas.openxmlformats.org/markup-compatibility/2006" xmlns:p14="http://schemas.microsoft.com/office/powerpoint/2010/main">
+          <mc:Choice Requires="p14">
+            <p:contentPart p14:bwMode="auto" r:id="rId18">
+              <p14:nvContentPartPr>
+                <p14:cNvPr id="12" name="Ink 11">
+                  <a:extLst>
+                    <a:ext uri="{FF2B5EF4-FFF2-40B4-BE49-F238E27FC236}">
+                      <a16:creationId xmlns:a16="http://schemas.microsoft.com/office/drawing/2014/main" id="{7A581A61-FB1B-497C-C6A5-42A36F2B3079}"/>
+                    </a:ext>
+                  </a:extLst>
+                </p14:cNvPr>
+                <p14:cNvContentPartPr/>
+                <p14:nvPr/>
+              </p14:nvContentPartPr>
+              <p14:xfrm>
+                <a:off x="7858600" y="2971480"/>
+                <a:ext cx="117720" cy="122040"/>
+              </p14:xfrm>
+            </p:contentPart>
+          </mc:Choice>
+          <mc:Fallback xmlns="">
+            <p:pic>
+              <p:nvPicPr>
+                <p:cNvPr id="24" name="Ink 23">
+                  <a:extLst>
+                    <a:ext uri="{FF2B5EF4-FFF2-40B4-BE49-F238E27FC236}">
+                      <a16:creationId xmlns:a16="http://schemas.microsoft.com/office/drawing/2014/main" id="{4937ACB2-4FE0-0DFA-8E66-88400B7FCD25}"/>
+                    </a:ext>
+                  </a:extLst>
+                </p:cNvPr>
+                <p:cNvPicPr/>
+                <p:nvPr/>
+              </p:nvPicPr>
+              <p:blipFill>
+                <a:blip r:embed="rId15"/>
+                <a:stretch>
+                  <a:fillRect/>
+                </a:stretch>
+              </p:blipFill>
+              <p:spPr>
+                <a:xfrm>
+                  <a:off x="7852480" y="2965360"/>
+                  <a:ext cx="129960" cy="134280"/>
+                </a:xfrm>
+                <a:prstGeom prst="rect">
+                  <a:avLst/>
+                </a:prstGeom>
+              </p:spPr>
+            </p:pic>
+          </mc:Fallback>
+        </mc:AlternateContent>
+      </p:grpSp>
+    </p:spTree>
+    <p:extLst>
+      <p:ext uri="{BB962C8B-B14F-4D97-AF65-F5344CB8AC3E}">
+        <p14:creationId xmlns:p14="http://schemas.microsoft.com/office/powerpoint/2010/main" val="4076295346"/>
+      </p:ext>
+    </p:extLst>
+  </p:cSld>
+  <p:clrMapOvr>
+    <a:masterClrMapping/>
+  </p:clrMapOvr>
+  <mc:AlternateContent xmlns:mc="http://schemas.openxmlformats.org/markup-compatibility/2006" xmlns:p14="http://schemas.microsoft.com/office/powerpoint/2010/main">
+    <mc:Choice Requires="p14">
+      <p:transition spd="med" p14:dur="700">
+        <p:fade/>
+      </p:transition>
+    </mc:Choice>
+    <mc:Fallback xmlns="">
+      <p:transition spd="med">
+        <p:fade/>
+      </p:transition>
+    </mc:Fallback>
+  </mc:AlternateContent>
+</p:sld>
+</file>
+
+<file path=ppt/slides/slide11.xml><?xml version="1.0" encoding="utf-8"?>
+<p:sld xmlns:a="http://schemas.openxmlformats.org/drawingml/2006/main" xmlns:r="http://schemas.openxmlformats.org/officeDocument/2006/relationships" xmlns:p="http://schemas.openxmlformats.org/presentationml/2006/main">
+  <p:cSld>
+    <p:spTree>
+      <p:nvGrpSpPr>
         <p:cNvPr id="1" name=""/>
         <p:cNvGrpSpPr/>
         <p:nvPr/>
@@ -7539,7 +8363,7 @@
 </p:sld>
 </file>
 
-<file path=ppt/slides/slide11.xml><?xml version="1.0" encoding="utf-8"?>
+<file path=ppt/slides/slide12.xml><?xml version="1.0" encoding="utf-8"?>
 <p:sld xmlns:a="http://schemas.openxmlformats.org/drawingml/2006/main" xmlns:r="http://schemas.openxmlformats.org/officeDocument/2006/relationships" xmlns:p="http://schemas.openxmlformats.org/presentationml/2006/main">
   <p:cSld>
     <p:spTree>
@@ -7740,7 +8564,7 @@
 </p:sld>
 </file>
 
-<file path=ppt/slides/slide12.xml><?xml version="1.0" encoding="utf-8"?>
+<file path=ppt/slides/slide13.xml><?xml version="1.0" encoding="utf-8"?>
 <p:sld xmlns:a="http://schemas.openxmlformats.org/drawingml/2006/main" xmlns:r="http://schemas.openxmlformats.org/officeDocument/2006/relationships" xmlns:p="http://schemas.openxmlformats.org/presentationml/2006/main">
   <p:cSld>
     <p:spTree>
@@ -7985,7 +8809,7 @@
 </p:sld>
 </file>
 
-<file path=ppt/slides/slide13.xml><?xml version="1.0" encoding="utf-8"?>
+<file path=ppt/slides/slide14.xml><?xml version="1.0" encoding="utf-8"?>
 <p:sld xmlns:a="http://schemas.openxmlformats.org/drawingml/2006/main" xmlns:r="http://schemas.openxmlformats.org/officeDocument/2006/relationships" xmlns:p="http://schemas.openxmlformats.org/presentationml/2006/main">
   <p:cSld>
     <p:spTree>
@@ -8063,7 +8887,7 @@
 </p:sld>
 </file>
 
-<file path=ppt/slides/slide14.xml><?xml version="1.0" encoding="utf-8"?>
+<file path=ppt/slides/slide15.xml><?xml version="1.0" encoding="utf-8"?>
 <p:sld xmlns:a="http://schemas.openxmlformats.org/drawingml/2006/main" xmlns:r="http://schemas.openxmlformats.org/officeDocument/2006/relationships" xmlns:p="http://schemas.openxmlformats.org/presentationml/2006/main">
   <p:cSld>
     <p:spTree>
@@ -8246,7 +9070,7 @@
 </p:sld>
 </file>
 
-<file path=ppt/slides/slide15.xml><?xml version="1.0" encoding="utf-8"?>
+<file path=ppt/slides/slide16.xml><?xml version="1.0" encoding="utf-8"?>
 <p:sld xmlns:a="http://schemas.openxmlformats.org/drawingml/2006/main" xmlns:r="http://schemas.openxmlformats.org/officeDocument/2006/relationships" xmlns:p="http://schemas.openxmlformats.org/presentationml/2006/main">
   <p:cSld>
     <p:spTree>
@@ -8451,7 +9275,7 @@
 </p:sld>
 </file>
 
-<file path=ppt/slides/slide16.xml><?xml version="1.0" encoding="utf-8"?>
+<file path=ppt/slides/slide17.xml><?xml version="1.0" encoding="utf-8"?>
 <p:sld xmlns:a="http://schemas.openxmlformats.org/drawingml/2006/main" xmlns:r="http://schemas.openxmlformats.org/officeDocument/2006/relationships" xmlns:p="http://schemas.openxmlformats.org/presentationml/2006/main">
   <p:cSld>
     <p:spTree>
@@ -9034,7 +9858,7 @@
 </p:sld>
 </file>
 
-<file path=ppt/slides/slide17.xml><?xml version="1.0" encoding="utf-8"?>
+<file path=ppt/slides/slide18.xml><?xml version="1.0" encoding="utf-8"?>
 <p:sld xmlns:a="http://schemas.openxmlformats.org/drawingml/2006/main" xmlns:r="http://schemas.openxmlformats.org/officeDocument/2006/relationships" xmlns:p="http://schemas.openxmlformats.org/presentationml/2006/main">
   <p:cSld>
     <p:spTree>
@@ -9171,7 +9995,7 @@
 </p:sld>
 </file>
 
-<file path=ppt/slides/slide18.xml><?xml version="1.0" encoding="utf-8"?>
+<file path=ppt/slides/slide19.xml><?xml version="1.0" encoding="utf-8"?>
 <p:sld xmlns:a="http://schemas.openxmlformats.org/drawingml/2006/main" xmlns:r="http://schemas.openxmlformats.org/officeDocument/2006/relationships" xmlns:p="http://schemas.openxmlformats.org/presentationml/2006/main">
   <p:cSld>
     <p:spTree>
@@ -9350,7 +10174,211 @@
 </p:sld>
 </file>
 
-<file path=ppt/slides/slide19.xml><?xml version="1.0" encoding="utf-8"?>
+<file path=ppt/slides/slide2.xml><?xml version="1.0" encoding="utf-8"?>
+<p:sld xmlns:a="http://schemas.openxmlformats.org/drawingml/2006/main" xmlns:r="http://schemas.openxmlformats.org/officeDocument/2006/relationships" xmlns:p="http://schemas.openxmlformats.org/presentationml/2006/main">
+  <p:cSld>
+    <p:spTree>
+      <p:nvGrpSpPr>
+        <p:cNvPr id="1" name=""/>
+        <p:cNvGrpSpPr/>
+        <p:nvPr/>
+      </p:nvGrpSpPr>
+      <p:grpSpPr>
+        <a:xfrm>
+          <a:off x="0" y="0"/>
+          <a:ext cx="0" cy="0"/>
+          <a:chOff x="0" y="0"/>
+          <a:chExt cx="0" cy="0"/>
+        </a:xfrm>
+      </p:grpSpPr>
+      <p:sp>
+        <p:nvSpPr>
+          <p:cNvPr id="2" name="Title 1">
+            <a:extLst>
+              <a:ext uri="{FF2B5EF4-FFF2-40B4-BE49-F238E27FC236}">
+                <a16:creationId xmlns:a16="http://schemas.microsoft.com/office/drawing/2014/main" id="{08AE2DED-E00F-8D55-C9F9-F02FA9C83AD0}"/>
+              </a:ext>
+            </a:extLst>
+          </p:cNvPr>
+          <p:cNvSpPr>
+            <a:spLocks noGrp="1"/>
+          </p:cNvSpPr>
+          <p:nvPr>
+            <p:ph type="title"/>
+          </p:nvPr>
+        </p:nvSpPr>
+        <p:spPr/>
+        <p:txBody>
+          <a:bodyPr/>
+          <a:lstStyle/>
+          <a:p>
+            <a:r>
+              <a:rPr lang="fr-FR" dirty="0" err="1"/>
+              <a:t>Outline</a:t>
+            </a:r>
+            <a:r>
+              <a:rPr lang="fr-FR" dirty="0"/>
+              <a:t> of the class</a:t>
+            </a:r>
+          </a:p>
+        </p:txBody>
+      </p:sp>
+      <p:sp>
+        <p:nvSpPr>
+          <p:cNvPr id="3" name="Content Placeholder 2">
+            <a:extLst>
+              <a:ext uri="{FF2B5EF4-FFF2-40B4-BE49-F238E27FC236}">
+                <a16:creationId xmlns:a16="http://schemas.microsoft.com/office/drawing/2014/main" id="{08838BA3-12FC-4A9A-D913-8A7375B051B9}"/>
+              </a:ext>
+            </a:extLst>
+          </p:cNvPr>
+          <p:cNvSpPr>
+            <a:spLocks noGrp="1"/>
+          </p:cNvSpPr>
+          <p:nvPr>
+            <p:ph idx="1"/>
+          </p:nvPr>
+        </p:nvSpPr>
+        <p:spPr>
+          <a:xfrm>
+            <a:off x="838200" y="1825625"/>
+            <a:ext cx="10751820" cy="4351338"/>
+          </a:xfrm>
+        </p:spPr>
+        <p:txBody>
+          <a:bodyPr>
+            <a:normAutofit lnSpcReduction="10000"/>
+          </a:bodyPr>
+          <a:lstStyle/>
+          <a:p>
+            <a:pPr marL="514350" indent="-514350">
+              <a:buFont typeface="+mj-lt"/>
+              <a:buAutoNum type="arabicPeriod"/>
+            </a:pPr>
+            <a:r>
+              <a:rPr lang="fr-FR" sz="2400" dirty="0"/>
+              <a:t>Introduction to Deep Learning</a:t>
+            </a:r>
+          </a:p>
+          <a:p>
+            <a:pPr marL="514350" indent="-514350">
+              <a:buFont typeface="+mj-lt"/>
+              <a:buAutoNum type="arabicPeriod"/>
+            </a:pPr>
+            <a:r>
+              <a:rPr lang="fr-FR" sz="2400" dirty="0"/>
+              <a:t>PyTorch</a:t>
+            </a:r>
+          </a:p>
+          <a:p>
+            <a:pPr marL="514350" indent="-514350">
+              <a:buFont typeface="+mj-lt"/>
+              <a:buAutoNum type="arabicPeriod"/>
+            </a:pPr>
+            <a:r>
+              <a:rPr lang="en-US" sz="2400" b="1" dirty="0"/>
+              <a:t>Optimizers review. Types of Machine Learning problems and their losses.</a:t>
+            </a:r>
+          </a:p>
+          <a:p>
+            <a:pPr marL="514350" indent="-514350">
+              <a:buFont typeface="+mj-lt"/>
+              <a:buAutoNum type="arabicPeriod"/>
+            </a:pPr>
+            <a:r>
+              <a:rPr lang="en-US" sz="2400" dirty="0"/>
+              <a:t>Layers Types 1 (linear: width vs depth)</a:t>
+            </a:r>
+          </a:p>
+          <a:p>
+            <a:pPr marL="514350" indent="-514350">
+              <a:buFont typeface="+mj-lt"/>
+              <a:buAutoNum type="arabicPeriod"/>
+            </a:pPr>
+            <a:r>
+              <a:rPr lang="en-US" sz="2400" dirty="0"/>
+              <a:t>Layers Types 2 (conv, pooling &amp; </a:t>
+            </a:r>
+            <a:r>
+              <a:rPr lang="en-US" sz="2400" dirty="0" err="1"/>
+              <a:t>softmax</a:t>
+            </a:r>
+            <a:r>
+              <a:rPr lang="en-US" sz="2400" dirty="0"/>
+              <a:t>)</a:t>
+            </a:r>
+          </a:p>
+          <a:p>
+            <a:pPr marL="514350" indent="-514350">
+              <a:buFont typeface="+mj-lt"/>
+              <a:buAutoNum type="arabicPeriod"/>
+            </a:pPr>
+            <a:r>
+              <a:rPr lang="en-US" sz="2400" dirty="0"/>
+              <a:t>Architectures (RNN) &amp; Transfer Learning</a:t>
+            </a:r>
+          </a:p>
+          <a:p>
+            <a:pPr marL="514350" indent="-514350">
+              <a:buFont typeface="+mj-lt"/>
+              <a:buAutoNum type="arabicPeriod"/>
+            </a:pPr>
+            <a:r>
+              <a:rPr lang="en-US" sz="2400" dirty="0"/>
+              <a:t>Practical Exercises and hyperparameter optimization</a:t>
+            </a:r>
+          </a:p>
+          <a:p>
+            <a:pPr marL="514350" indent="-514350">
+              <a:buFont typeface="+mj-lt"/>
+              <a:buAutoNum type="arabicPeriod"/>
+            </a:pPr>
+            <a:r>
+              <a:rPr lang="en-US" sz="2400" dirty="0"/>
+              <a:t>Attention. Transformers.</a:t>
+            </a:r>
+          </a:p>
+          <a:p>
+            <a:pPr marL="514350" indent="-514350">
+              <a:buFont typeface="+mj-lt"/>
+              <a:buAutoNum type="arabicPeriod"/>
+            </a:pPr>
+            <a:r>
+              <a:rPr lang="en-US" sz="2400" dirty="0"/>
+              <a:t>Text Generation. </a:t>
+            </a:r>
+            <a:r>
+              <a:rPr lang="en-GB" sz="2400" dirty="0"/>
+              <a:t>Low-Rank Adaptation of Large Language Models</a:t>
+            </a:r>
+            <a:endParaRPr lang="en-US" sz="2400" dirty="0"/>
+          </a:p>
+          <a:p>
+            <a:pPr marL="514350" indent="-514350">
+              <a:buFont typeface="+mj-lt"/>
+              <a:buAutoNum type="arabicPeriod"/>
+            </a:pPr>
+            <a:r>
+              <a:rPr lang="en-US" sz="2400" dirty="0"/>
+              <a:t>Exam</a:t>
+            </a:r>
+          </a:p>
+        </p:txBody>
+      </p:sp>
+    </p:spTree>
+    <p:extLst>
+      <p:ext uri="{BB962C8B-B14F-4D97-AF65-F5344CB8AC3E}">
+        <p14:creationId xmlns:p14="http://schemas.microsoft.com/office/powerpoint/2010/main" val="2821173735"/>
+      </p:ext>
+    </p:extLst>
+  </p:cSld>
+  <p:clrMapOvr>
+    <a:masterClrMapping/>
+  </p:clrMapOvr>
+</p:sld>
+</file>
+
+<file path=ppt/slides/slide20.xml><?xml version="1.0" encoding="utf-8"?>
 <p:sld xmlns:a="http://schemas.openxmlformats.org/drawingml/2006/main" xmlns:r="http://schemas.openxmlformats.org/officeDocument/2006/relationships" xmlns:p="http://schemas.openxmlformats.org/presentationml/2006/main">
   <p:cSld>
     <p:spTree>
@@ -9875,211 +10903,7 @@
 </p:sld>
 </file>
 
-<file path=ppt/slides/slide2.xml><?xml version="1.0" encoding="utf-8"?>
-<p:sld xmlns:a="http://schemas.openxmlformats.org/drawingml/2006/main" xmlns:r="http://schemas.openxmlformats.org/officeDocument/2006/relationships" xmlns:p="http://schemas.openxmlformats.org/presentationml/2006/main">
-  <p:cSld>
-    <p:spTree>
-      <p:nvGrpSpPr>
-        <p:cNvPr id="1" name=""/>
-        <p:cNvGrpSpPr/>
-        <p:nvPr/>
-      </p:nvGrpSpPr>
-      <p:grpSpPr>
-        <a:xfrm>
-          <a:off x="0" y="0"/>
-          <a:ext cx="0" cy="0"/>
-          <a:chOff x="0" y="0"/>
-          <a:chExt cx="0" cy="0"/>
-        </a:xfrm>
-      </p:grpSpPr>
-      <p:sp>
-        <p:nvSpPr>
-          <p:cNvPr id="2" name="Title 1">
-            <a:extLst>
-              <a:ext uri="{FF2B5EF4-FFF2-40B4-BE49-F238E27FC236}">
-                <a16:creationId xmlns:a16="http://schemas.microsoft.com/office/drawing/2014/main" id="{08AE2DED-E00F-8D55-C9F9-F02FA9C83AD0}"/>
-              </a:ext>
-            </a:extLst>
-          </p:cNvPr>
-          <p:cNvSpPr>
-            <a:spLocks noGrp="1"/>
-          </p:cNvSpPr>
-          <p:nvPr>
-            <p:ph type="title"/>
-          </p:nvPr>
-        </p:nvSpPr>
-        <p:spPr/>
-        <p:txBody>
-          <a:bodyPr/>
-          <a:lstStyle/>
-          <a:p>
-            <a:r>
-              <a:rPr lang="fr-FR" dirty="0" err="1"/>
-              <a:t>Outline</a:t>
-            </a:r>
-            <a:r>
-              <a:rPr lang="fr-FR" dirty="0"/>
-              <a:t> of the class</a:t>
-            </a:r>
-          </a:p>
-        </p:txBody>
-      </p:sp>
-      <p:sp>
-        <p:nvSpPr>
-          <p:cNvPr id="3" name="Content Placeholder 2">
-            <a:extLst>
-              <a:ext uri="{FF2B5EF4-FFF2-40B4-BE49-F238E27FC236}">
-                <a16:creationId xmlns:a16="http://schemas.microsoft.com/office/drawing/2014/main" id="{08838BA3-12FC-4A9A-D913-8A7375B051B9}"/>
-              </a:ext>
-            </a:extLst>
-          </p:cNvPr>
-          <p:cNvSpPr>
-            <a:spLocks noGrp="1"/>
-          </p:cNvSpPr>
-          <p:nvPr>
-            <p:ph idx="1"/>
-          </p:nvPr>
-        </p:nvSpPr>
-        <p:spPr>
-          <a:xfrm>
-            <a:off x="838200" y="1825625"/>
-            <a:ext cx="10751820" cy="4351338"/>
-          </a:xfrm>
-        </p:spPr>
-        <p:txBody>
-          <a:bodyPr>
-            <a:normAutofit lnSpcReduction="10000"/>
-          </a:bodyPr>
-          <a:lstStyle/>
-          <a:p>
-            <a:pPr marL="514350" indent="-514350">
-              <a:buFont typeface="+mj-lt"/>
-              <a:buAutoNum type="arabicPeriod"/>
-            </a:pPr>
-            <a:r>
-              <a:rPr lang="fr-FR" sz="2400" dirty="0"/>
-              <a:t>Introduction to Deep Learning</a:t>
-            </a:r>
-          </a:p>
-          <a:p>
-            <a:pPr marL="514350" indent="-514350">
-              <a:buFont typeface="+mj-lt"/>
-              <a:buAutoNum type="arabicPeriod"/>
-            </a:pPr>
-            <a:r>
-              <a:rPr lang="fr-FR" sz="2400" dirty="0"/>
-              <a:t>PyTorch</a:t>
-            </a:r>
-          </a:p>
-          <a:p>
-            <a:pPr marL="514350" indent="-514350">
-              <a:buFont typeface="+mj-lt"/>
-              <a:buAutoNum type="arabicPeriod"/>
-            </a:pPr>
-            <a:r>
-              <a:rPr lang="en-US" sz="2400" b="1" dirty="0"/>
-              <a:t>Optimizers review. Types of Machine Learning problems and their losses.</a:t>
-            </a:r>
-          </a:p>
-          <a:p>
-            <a:pPr marL="514350" indent="-514350">
-              <a:buFont typeface="+mj-lt"/>
-              <a:buAutoNum type="arabicPeriod"/>
-            </a:pPr>
-            <a:r>
-              <a:rPr lang="en-US" sz="2400" dirty="0"/>
-              <a:t>Layers Types 1 (linear: width vs depth)</a:t>
-            </a:r>
-          </a:p>
-          <a:p>
-            <a:pPr marL="514350" indent="-514350">
-              <a:buFont typeface="+mj-lt"/>
-              <a:buAutoNum type="arabicPeriod"/>
-            </a:pPr>
-            <a:r>
-              <a:rPr lang="en-US" sz="2400" dirty="0"/>
-              <a:t>Layers Types 2 (conv, pooling &amp; </a:t>
-            </a:r>
-            <a:r>
-              <a:rPr lang="en-US" sz="2400" dirty="0" err="1"/>
-              <a:t>softmax</a:t>
-            </a:r>
-            <a:r>
-              <a:rPr lang="en-US" sz="2400" dirty="0"/>
-              <a:t>)</a:t>
-            </a:r>
-          </a:p>
-          <a:p>
-            <a:pPr marL="514350" indent="-514350">
-              <a:buFont typeface="+mj-lt"/>
-              <a:buAutoNum type="arabicPeriod"/>
-            </a:pPr>
-            <a:r>
-              <a:rPr lang="en-US" sz="2400" dirty="0"/>
-              <a:t>Architectures (RNN) &amp; Transfer Learning</a:t>
-            </a:r>
-          </a:p>
-          <a:p>
-            <a:pPr marL="514350" indent="-514350">
-              <a:buFont typeface="+mj-lt"/>
-              <a:buAutoNum type="arabicPeriod"/>
-            </a:pPr>
-            <a:r>
-              <a:rPr lang="en-US" sz="2400" dirty="0"/>
-              <a:t>Practical Exercises and hyperparameter optimization</a:t>
-            </a:r>
-          </a:p>
-          <a:p>
-            <a:pPr marL="514350" indent="-514350">
-              <a:buFont typeface="+mj-lt"/>
-              <a:buAutoNum type="arabicPeriod"/>
-            </a:pPr>
-            <a:r>
-              <a:rPr lang="en-US" sz="2400" dirty="0"/>
-              <a:t>Attention. Transformers.</a:t>
-            </a:r>
-          </a:p>
-          <a:p>
-            <a:pPr marL="514350" indent="-514350">
-              <a:buFont typeface="+mj-lt"/>
-              <a:buAutoNum type="arabicPeriod"/>
-            </a:pPr>
-            <a:r>
-              <a:rPr lang="en-US" sz="2400" dirty="0"/>
-              <a:t>Text Generation. </a:t>
-            </a:r>
-            <a:r>
-              <a:rPr lang="en-GB" sz="2400" dirty="0"/>
-              <a:t>Low-Rank Adaptation of Large Language Models</a:t>
-            </a:r>
-            <a:endParaRPr lang="en-US" sz="2400" dirty="0"/>
-          </a:p>
-          <a:p>
-            <a:pPr marL="514350" indent="-514350">
-              <a:buFont typeface="+mj-lt"/>
-              <a:buAutoNum type="arabicPeriod"/>
-            </a:pPr>
-            <a:r>
-              <a:rPr lang="en-US" sz="2400" dirty="0"/>
-              <a:t>Exam</a:t>
-            </a:r>
-          </a:p>
-        </p:txBody>
-      </p:sp>
-    </p:spTree>
-    <p:extLst>
-      <p:ext uri="{BB962C8B-B14F-4D97-AF65-F5344CB8AC3E}">
-        <p14:creationId xmlns:p14="http://schemas.microsoft.com/office/powerpoint/2010/main" val="2821173735"/>
-      </p:ext>
-    </p:extLst>
-  </p:cSld>
-  <p:clrMapOvr>
-    <a:masterClrMapping/>
-  </p:clrMapOvr>
-</p:sld>
-</file>
-
-<file path=ppt/slides/slide20.xml><?xml version="1.0" encoding="utf-8"?>
+<file path=ppt/slides/slide21.xml><?xml version="1.0" encoding="utf-8"?>
 <p:sld xmlns:a="http://schemas.openxmlformats.org/drawingml/2006/main" xmlns:r="http://schemas.openxmlformats.org/officeDocument/2006/relationships" xmlns:p="http://schemas.openxmlformats.org/presentationml/2006/main">
   <p:cSld>
     <p:spTree>
@@ -10258,7 +11082,7 @@
 </p:sld>
 </file>
 
-<file path=ppt/slides/slide21.xml><?xml version="1.0" encoding="utf-8"?>
+<file path=ppt/slides/slide22.xml><?xml version="1.0" encoding="utf-8"?>
 <p:sld xmlns:a="http://schemas.openxmlformats.org/drawingml/2006/main" xmlns:r="http://schemas.openxmlformats.org/officeDocument/2006/relationships" xmlns:p="http://schemas.openxmlformats.org/presentationml/2006/main">
   <p:cSld>
     <p:spTree>
@@ -11044,7 +11868,7 @@
 </p:sld>
 </file>
 
-<file path=ppt/slides/slide22.xml><?xml version="1.0" encoding="utf-8"?>
+<file path=ppt/slides/slide23.xml><?xml version="1.0" encoding="utf-8"?>
 <p:sld xmlns:a="http://schemas.openxmlformats.org/drawingml/2006/main" xmlns:r="http://schemas.openxmlformats.org/officeDocument/2006/relationships" xmlns:p="http://schemas.openxmlformats.org/presentationml/2006/main">
   <p:cSld>
     <p:spTree>
@@ -11416,7 +12240,7 @@
 </p:sld>
 </file>
 
-<file path=ppt/slides/slide23.xml><?xml version="1.0" encoding="utf-8"?>
+<file path=ppt/slides/slide24.xml><?xml version="1.0" encoding="utf-8"?>
 <p:sld xmlns:a="http://schemas.openxmlformats.org/drawingml/2006/main" xmlns:r="http://schemas.openxmlformats.org/officeDocument/2006/relationships" xmlns:p="http://schemas.openxmlformats.org/presentationml/2006/main">
   <p:cSld>
     <p:spTree>
@@ -12510,7 +13334,7 @@
 </p:sld>
 </file>
 
-<file path=ppt/slides/slide24.xml><?xml version="1.0" encoding="utf-8"?>
+<file path=ppt/slides/slide25.xml><?xml version="1.0" encoding="utf-8"?>
 <p:sld xmlns:a="http://schemas.openxmlformats.org/drawingml/2006/main" xmlns:r="http://schemas.openxmlformats.org/officeDocument/2006/relationships" xmlns:p="http://schemas.openxmlformats.org/presentationml/2006/main">
   <p:cSld>
     <p:spTree>
@@ -12676,7 +13500,7 @@
 </p:sld>
 </file>
 
-<file path=ppt/slides/slide25.xml><?xml version="1.0" encoding="utf-8"?>
+<file path=ppt/slides/slide26.xml><?xml version="1.0" encoding="utf-8"?>
 <p:sld xmlns:a="http://schemas.openxmlformats.org/drawingml/2006/main" xmlns:r="http://schemas.openxmlformats.org/officeDocument/2006/relationships" xmlns:p="http://schemas.openxmlformats.org/presentationml/2006/main">
   <p:cSld>
     <p:spTree>
@@ -17498,8 +18322,8 @@
             <a:chExt cx="1246680" cy="1256400"/>
           </a:xfrm>
         </p:grpSpPr>
-        <mc:AlternateContent xmlns:mc="http://schemas.openxmlformats.org/markup-compatibility/2006">
-          <mc:Choice xmlns:p14="http://schemas.microsoft.com/office/powerpoint/2010/main" Requires="p14">
+        <mc:AlternateContent xmlns:mc="http://schemas.openxmlformats.org/markup-compatibility/2006" xmlns:p14="http://schemas.microsoft.com/office/powerpoint/2010/main">
+          <mc:Choice Requires="p14">
             <p:contentPart p14:bwMode="auto" r:id="rId4">
               <p14:nvContentPartPr>
                 <p14:cNvPr id="18" name="Ink 17">
@@ -17518,7 +18342,7 @@
               </p14:xfrm>
             </p:contentPart>
           </mc:Choice>
-          <mc:Fallback>
+          <mc:Fallback xmlns="">
             <p:pic>
               <p:nvPicPr>
                 <p:cNvPr id="18" name="Ink 17">
@@ -17549,8 +18373,8 @@
             </p:pic>
           </mc:Fallback>
         </mc:AlternateContent>
-        <mc:AlternateContent xmlns:mc="http://schemas.openxmlformats.org/markup-compatibility/2006">
-          <mc:Choice xmlns:p14="http://schemas.microsoft.com/office/powerpoint/2010/main" Requires="p14">
+        <mc:AlternateContent xmlns:mc="http://schemas.openxmlformats.org/markup-compatibility/2006" xmlns:p14="http://schemas.microsoft.com/office/powerpoint/2010/main">
+          <mc:Choice Requires="p14">
             <p:contentPart p14:bwMode="auto" r:id="rId6">
               <p14:nvContentPartPr>
                 <p14:cNvPr id="19" name="Ink 18">
@@ -17569,7 +18393,7 @@
               </p14:xfrm>
             </p:contentPart>
           </mc:Choice>
-          <mc:Fallback>
+          <mc:Fallback xmlns="">
             <p:pic>
               <p:nvPicPr>
                 <p:cNvPr id="19" name="Ink 18">
@@ -17600,8 +18424,8 @@
             </p:pic>
           </mc:Fallback>
         </mc:AlternateContent>
-        <mc:AlternateContent xmlns:mc="http://schemas.openxmlformats.org/markup-compatibility/2006">
-          <mc:Choice xmlns:p14="http://schemas.microsoft.com/office/powerpoint/2010/main" Requires="p14">
+        <mc:AlternateContent xmlns:mc="http://schemas.openxmlformats.org/markup-compatibility/2006" xmlns:p14="http://schemas.microsoft.com/office/powerpoint/2010/main">
+          <mc:Choice Requires="p14">
             <p:contentPart p14:bwMode="auto" r:id="rId8">
               <p14:nvContentPartPr>
                 <p14:cNvPr id="20" name="Ink 19">
@@ -17620,7 +18444,7 @@
               </p14:xfrm>
             </p:contentPart>
           </mc:Choice>
-          <mc:Fallback>
+          <mc:Fallback xmlns="">
             <p:pic>
               <p:nvPicPr>
                 <p:cNvPr id="20" name="Ink 19">
@@ -17672,8 +18496,8 @@
             <a:chExt cx="1174320" cy="533880"/>
           </a:xfrm>
         </p:grpSpPr>
-        <mc:AlternateContent xmlns:mc="http://schemas.openxmlformats.org/markup-compatibility/2006">
-          <mc:Choice xmlns:p14="http://schemas.microsoft.com/office/powerpoint/2010/main" Requires="p14">
+        <mc:AlternateContent xmlns:mc="http://schemas.openxmlformats.org/markup-compatibility/2006" xmlns:p14="http://schemas.microsoft.com/office/powerpoint/2010/main">
+          <mc:Choice Requires="p14">
             <p:contentPart p14:bwMode="auto" r:id="rId10">
               <p14:nvContentPartPr>
                 <p14:cNvPr id="22" name="Ink 21">
@@ -17692,7 +18516,7 @@
               </p14:xfrm>
             </p:contentPart>
           </mc:Choice>
-          <mc:Fallback>
+          <mc:Fallback xmlns="">
             <p:pic>
               <p:nvPicPr>
                 <p:cNvPr id="22" name="Ink 21">
@@ -17723,8 +18547,8 @@
             </p:pic>
           </mc:Fallback>
         </mc:AlternateContent>
-        <mc:AlternateContent xmlns:mc="http://schemas.openxmlformats.org/markup-compatibility/2006">
-          <mc:Choice xmlns:p14="http://schemas.microsoft.com/office/powerpoint/2010/main" Requires="p14">
+        <mc:AlternateContent xmlns:mc="http://schemas.openxmlformats.org/markup-compatibility/2006" xmlns:p14="http://schemas.microsoft.com/office/powerpoint/2010/main">
+          <mc:Choice Requires="p14">
             <p:contentPart p14:bwMode="auto" r:id="rId12">
               <p14:nvContentPartPr>
                 <p14:cNvPr id="23" name="Ink 22">
@@ -17743,7 +18567,7 @@
               </p14:xfrm>
             </p:contentPart>
           </mc:Choice>
-          <mc:Fallback>
+          <mc:Fallback xmlns="">
             <p:pic>
               <p:nvPicPr>
                 <p:cNvPr id="23" name="Ink 22">
@@ -17774,8 +18598,8 @@
             </p:pic>
           </mc:Fallback>
         </mc:AlternateContent>
-        <mc:AlternateContent xmlns:mc="http://schemas.openxmlformats.org/markup-compatibility/2006">
-          <mc:Choice xmlns:p14="http://schemas.microsoft.com/office/powerpoint/2010/main" Requires="p14">
+        <mc:AlternateContent xmlns:mc="http://schemas.openxmlformats.org/markup-compatibility/2006" xmlns:p14="http://schemas.microsoft.com/office/powerpoint/2010/main">
+          <mc:Choice Requires="p14">
             <p:contentPart p14:bwMode="auto" r:id="rId14">
               <p14:nvContentPartPr>
                 <p14:cNvPr id="24" name="Ink 23">
@@ -17794,7 +18618,7 @@
               </p14:xfrm>
             </p:contentPart>
           </mc:Choice>
-          <mc:Fallback>
+          <mc:Fallback xmlns="">
             <p:pic>
               <p:nvPicPr>
                 <p:cNvPr id="24" name="Ink 23">
@@ -17846,8 +18670,8 @@
             <a:chExt cx="570600" cy="120600"/>
           </a:xfrm>
         </p:grpSpPr>
-        <mc:AlternateContent xmlns:mc="http://schemas.openxmlformats.org/markup-compatibility/2006">
-          <mc:Choice xmlns:p14="http://schemas.microsoft.com/office/powerpoint/2010/main" Requires="p14">
+        <mc:AlternateContent xmlns:mc="http://schemas.openxmlformats.org/markup-compatibility/2006" xmlns:p14="http://schemas.microsoft.com/office/powerpoint/2010/main">
+          <mc:Choice Requires="p14">
             <p:contentPart p14:bwMode="auto" r:id="rId16">
               <p14:nvContentPartPr>
                 <p14:cNvPr id="26" name="Ink 25">
@@ -17866,7 +18690,7 @@
               </p14:xfrm>
             </p:contentPart>
           </mc:Choice>
-          <mc:Fallback>
+          <mc:Fallback xmlns="">
             <p:pic>
               <p:nvPicPr>
                 <p:cNvPr id="26" name="Ink 25">
@@ -17897,8 +18721,8 @@
             </p:pic>
           </mc:Fallback>
         </mc:AlternateContent>
-        <mc:AlternateContent xmlns:mc="http://schemas.openxmlformats.org/markup-compatibility/2006">
-          <mc:Choice xmlns:p14="http://schemas.microsoft.com/office/powerpoint/2010/main" Requires="p14">
+        <mc:AlternateContent xmlns:mc="http://schemas.openxmlformats.org/markup-compatibility/2006" xmlns:p14="http://schemas.microsoft.com/office/powerpoint/2010/main">
+          <mc:Choice Requires="p14">
             <p:contentPart p14:bwMode="auto" r:id="rId18">
               <p14:nvContentPartPr>
                 <p14:cNvPr id="27" name="Ink 26">
@@ -17917,7 +18741,7 @@
               </p14:xfrm>
             </p:contentPart>
           </mc:Choice>
-          <mc:Fallback>
+          <mc:Fallback xmlns="">
             <p:pic>
               <p:nvPicPr>
                 <p:cNvPr id="27" name="Ink 26">
@@ -17969,8 +18793,8 @@
             <a:chExt cx="3159000" cy="2388000"/>
           </a:xfrm>
         </p:grpSpPr>
-        <mc:AlternateContent xmlns:mc="http://schemas.openxmlformats.org/markup-compatibility/2006">
-          <mc:Choice xmlns:p14="http://schemas.microsoft.com/office/powerpoint/2010/main" Requires="p14">
+        <mc:AlternateContent xmlns:mc="http://schemas.openxmlformats.org/markup-compatibility/2006" xmlns:p14="http://schemas.microsoft.com/office/powerpoint/2010/main">
+          <mc:Choice Requires="p14">
             <p:contentPart p14:bwMode="auto" r:id="rId20">
               <p14:nvContentPartPr>
                 <p14:cNvPr id="28" name="Ink 27">
@@ -17989,7 +18813,7 @@
               </p14:xfrm>
             </p:contentPart>
           </mc:Choice>
-          <mc:Fallback>
+          <mc:Fallback xmlns="">
             <p:pic>
               <p:nvPicPr>
                 <p:cNvPr id="28" name="Ink 27">
@@ -18020,8 +18844,8 @@
             </p:pic>
           </mc:Fallback>
         </mc:AlternateContent>
-        <mc:AlternateContent xmlns:mc="http://schemas.openxmlformats.org/markup-compatibility/2006">
-          <mc:Choice xmlns:p14="http://schemas.microsoft.com/office/powerpoint/2010/main" Requires="p14">
+        <mc:AlternateContent xmlns:mc="http://schemas.openxmlformats.org/markup-compatibility/2006" xmlns:p14="http://schemas.microsoft.com/office/powerpoint/2010/main">
+          <mc:Choice Requires="p14">
             <p:contentPart p14:bwMode="auto" r:id="rId22">
               <p14:nvContentPartPr>
                 <p14:cNvPr id="30" name="Ink 29">
@@ -18040,7 +18864,7 @@
               </p14:xfrm>
             </p:contentPart>
           </mc:Choice>
-          <mc:Fallback>
+          <mc:Fallback xmlns="">
             <p:pic>
               <p:nvPicPr>
                 <p:cNvPr id="30" name="Ink 29">
@@ -18071,8 +18895,8 @@
             </p:pic>
           </mc:Fallback>
         </mc:AlternateContent>
-        <mc:AlternateContent xmlns:mc="http://schemas.openxmlformats.org/markup-compatibility/2006">
-          <mc:Choice xmlns:p14="http://schemas.microsoft.com/office/powerpoint/2010/main" Requires="p14">
+        <mc:AlternateContent xmlns:mc="http://schemas.openxmlformats.org/markup-compatibility/2006" xmlns:p14="http://schemas.microsoft.com/office/powerpoint/2010/main">
+          <mc:Choice Requires="p14">
             <p:contentPart p14:bwMode="auto" r:id="rId24">
               <p14:nvContentPartPr>
                 <p14:cNvPr id="32" name="Ink 31">
@@ -18091,7 +18915,7 @@
               </p14:xfrm>
             </p:contentPart>
           </mc:Choice>
-          <mc:Fallback>
+          <mc:Fallback xmlns="">
             <p:pic>
               <p:nvPicPr>
                 <p:cNvPr id="32" name="Ink 31">
@@ -18122,8 +18946,8 @@
             </p:pic>
           </mc:Fallback>
         </mc:AlternateContent>
-        <mc:AlternateContent xmlns:mc="http://schemas.openxmlformats.org/markup-compatibility/2006">
-          <mc:Choice xmlns:p14="http://schemas.microsoft.com/office/powerpoint/2010/main" Requires="p14">
+        <mc:AlternateContent xmlns:mc="http://schemas.openxmlformats.org/markup-compatibility/2006" xmlns:p14="http://schemas.microsoft.com/office/powerpoint/2010/main">
+          <mc:Choice Requires="p14">
             <p:contentPart p14:bwMode="auto" r:id="rId26">
               <p14:nvContentPartPr>
                 <p14:cNvPr id="33" name="Ink 32">
@@ -18142,7 +18966,7 @@
               </p14:xfrm>
             </p:contentPart>
           </mc:Choice>
-          <mc:Fallback>
+          <mc:Fallback xmlns="">
             <p:pic>
               <p:nvPicPr>
                 <p:cNvPr id="33" name="Ink 32">
@@ -18173,8 +18997,8 @@
             </p:pic>
           </mc:Fallback>
         </mc:AlternateContent>
-        <mc:AlternateContent xmlns:mc="http://schemas.openxmlformats.org/markup-compatibility/2006">
-          <mc:Choice xmlns:p14="http://schemas.microsoft.com/office/powerpoint/2010/main" Requires="p14">
+        <mc:AlternateContent xmlns:mc="http://schemas.openxmlformats.org/markup-compatibility/2006" xmlns:p14="http://schemas.microsoft.com/office/powerpoint/2010/main">
+          <mc:Choice Requires="p14">
             <p:contentPart p14:bwMode="auto" r:id="rId28">
               <p14:nvContentPartPr>
                 <p14:cNvPr id="34" name="Ink 33">
@@ -18193,7 +19017,7 @@
               </p14:xfrm>
             </p:contentPart>
           </mc:Choice>
-          <mc:Fallback>
+          <mc:Fallback xmlns="">
             <p:pic>
               <p:nvPicPr>
                 <p:cNvPr id="34" name="Ink 33">
@@ -18224,8 +19048,8 @@
             </p:pic>
           </mc:Fallback>
         </mc:AlternateContent>
-        <mc:AlternateContent xmlns:mc="http://schemas.openxmlformats.org/markup-compatibility/2006">
-          <mc:Choice xmlns:p14="http://schemas.microsoft.com/office/powerpoint/2010/main" Requires="p14">
+        <mc:AlternateContent xmlns:mc="http://schemas.openxmlformats.org/markup-compatibility/2006" xmlns:p14="http://schemas.microsoft.com/office/powerpoint/2010/main">
+          <mc:Choice Requires="p14">
             <p:contentPart p14:bwMode="auto" r:id="rId30">
               <p14:nvContentPartPr>
                 <p14:cNvPr id="35" name="Ink 34">
@@ -18244,7 +19068,7 @@
               </p14:xfrm>
             </p:contentPart>
           </mc:Choice>
-          <mc:Fallback>
+          <mc:Fallback xmlns="">
             <p:pic>
               <p:nvPicPr>
                 <p:cNvPr id="35" name="Ink 34">
@@ -18275,8 +19099,8 @@
             </p:pic>
           </mc:Fallback>
         </mc:AlternateContent>
-        <mc:AlternateContent xmlns:mc="http://schemas.openxmlformats.org/markup-compatibility/2006">
-          <mc:Choice xmlns:p14="http://schemas.microsoft.com/office/powerpoint/2010/main" Requires="p14">
+        <mc:AlternateContent xmlns:mc="http://schemas.openxmlformats.org/markup-compatibility/2006" xmlns:p14="http://schemas.microsoft.com/office/powerpoint/2010/main">
+          <mc:Choice Requires="p14">
             <p:contentPart p14:bwMode="auto" r:id="rId32">
               <p14:nvContentPartPr>
                 <p14:cNvPr id="36" name="Ink 35">
@@ -18295,7 +19119,7 @@
               </p14:xfrm>
             </p:contentPart>
           </mc:Choice>
-          <mc:Fallback>
+          <mc:Fallback xmlns="">
             <p:pic>
               <p:nvPicPr>
                 <p:cNvPr id="36" name="Ink 35">
@@ -18326,8 +19150,8 @@
             </p:pic>
           </mc:Fallback>
         </mc:AlternateContent>
-        <mc:AlternateContent xmlns:mc="http://schemas.openxmlformats.org/markup-compatibility/2006">
-          <mc:Choice xmlns:p14="http://schemas.microsoft.com/office/powerpoint/2010/main" Requires="p14">
+        <mc:AlternateContent xmlns:mc="http://schemas.openxmlformats.org/markup-compatibility/2006" xmlns:p14="http://schemas.microsoft.com/office/powerpoint/2010/main">
+          <mc:Choice Requires="p14">
             <p:contentPart p14:bwMode="auto" r:id="rId34">
               <p14:nvContentPartPr>
                 <p14:cNvPr id="37" name="Ink 36">
@@ -18346,7 +19170,7 @@
               </p14:xfrm>
             </p:contentPart>
           </mc:Choice>
-          <mc:Fallback>
+          <mc:Fallback xmlns="">
             <p:pic>
               <p:nvPicPr>
                 <p:cNvPr id="37" name="Ink 36">
@@ -18377,8 +19201,8 @@
             </p:pic>
           </mc:Fallback>
         </mc:AlternateContent>
-        <mc:AlternateContent xmlns:mc="http://schemas.openxmlformats.org/markup-compatibility/2006">
-          <mc:Choice xmlns:p14="http://schemas.microsoft.com/office/powerpoint/2010/main" Requires="p14">
+        <mc:AlternateContent xmlns:mc="http://schemas.openxmlformats.org/markup-compatibility/2006" xmlns:p14="http://schemas.microsoft.com/office/powerpoint/2010/main">
+          <mc:Choice Requires="p14">
             <p:contentPart p14:bwMode="auto" r:id="rId36">
               <p14:nvContentPartPr>
                 <p14:cNvPr id="38" name="Ink 37">
@@ -18397,7 +19221,7 @@
               </p14:xfrm>
             </p:contentPart>
           </mc:Choice>
-          <mc:Fallback>
+          <mc:Fallback xmlns="">
             <p:pic>
               <p:nvPicPr>
                 <p:cNvPr id="38" name="Ink 37">
@@ -18428,8 +19252,8 @@
             </p:pic>
           </mc:Fallback>
         </mc:AlternateContent>
-        <mc:AlternateContent xmlns:mc="http://schemas.openxmlformats.org/markup-compatibility/2006">
-          <mc:Choice xmlns:p14="http://schemas.microsoft.com/office/powerpoint/2010/main" Requires="p14">
+        <mc:AlternateContent xmlns:mc="http://schemas.openxmlformats.org/markup-compatibility/2006" xmlns:p14="http://schemas.microsoft.com/office/powerpoint/2010/main">
+          <mc:Choice Requires="p14">
             <p:contentPart p14:bwMode="auto" r:id="rId38">
               <p14:nvContentPartPr>
                 <p14:cNvPr id="40" name="Ink 39">
@@ -18448,7 +19272,7 @@
               </p14:xfrm>
             </p:contentPart>
           </mc:Choice>
-          <mc:Fallback>
+          <mc:Fallback xmlns="">
             <p:pic>
               <p:nvPicPr>
                 <p:cNvPr id="40" name="Ink 39">
@@ -18479,8 +19303,8 @@
             </p:pic>
           </mc:Fallback>
         </mc:AlternateContent>
-        <mc:AlternateContent xmlns:mc="http://schemas.openxmlformats.org/markup-compatibility/2006">
-          <mc:Choice xmlns:p14="http://schemas.microsoft.com/office/powerpoint/2010/main" Requires="p14">
+        <mc:AlternateContent xmlns:mc="http://schemas.openxmlformats.org/markup-compatibility/2006" xmlns:p14="http://schemas.microsoft.com/office/powerpoint/2010/main">
+          <mc:Choice Requires="p14">
             <p:contentPart p14:bwMode="auto" r:id="rId40">
               <p14:nvContentPartPr>
                 <p14:cNvPr id="41" name="Ink 40">
@@ -18499,7 +19323,7 @@
               </p14:xfrm>
             </p:contentPart>
           </mc:Choice>
-          <mc:Fallback>
+          <mc:Fallback xmlns="">
             <p:pic>
               <p:nvPicPr>
                 <p:cNvPr id="41" name="Ink 40">
@@ -18530,8 +19354,8 @@
             </p:pic>
           </mc:Fallback>
         </mc:AlternateContent>
-        <mc:AlternateContent xmlns:mc="http://schemas.openxmlformats.org/markup-compatibility/2006">
-          <mc:Choice xmlns:p14="http://schemas.microsoft.com/office/powerpoint/2010/main" Requires="p14">
+        <mc:AlternateContent xmlns:mc="http://schemas.openxmlformats.org/markup-compatibility/2006" xmlns:p14="http://schemas.microsoft.com/office/powerpoint/2010/main">
+          <mc:Choice Requires="p14">
             <p:contentPart p14:bwMode="auto" r:id="rId42">
               <p14:nvContentPartPr>
                 <p14:cNvPr id="42" name="Ink 41">
@@ -18550,7 +19374,7 @@
               </p14:xfrm>
             </p:contentPart>
           </mc:Choice>
-          <mc:Fallback>
+          <mc:Fallback xmlns="">
             <p:pic>
               <p:nvPicPr>
                 <p:cNvPr id="42" name="Ink 41">
@@ -18581,8 +19405,8 @@
             </p:pic>
           </mc:Fallback>
         </mc:AlternateContent>
-        <mc:AlternateContent xmlns:mc="http://schemas.openxmlformats.org/markup-compatibility/2006">
-          <mc:Choice xmlns:p14="http://schemas.microsoft.com/office/powerpoint/2010/main" Requires="p14">
+        <mc:AlternateContent xmlns:mc="http://schemas.openxmlformats.org/markup-compatibility/2006" xmlns:p14="http://schemas.microsoft.com/office/powerpoint/2010/main">
+          <mc:Choice Requires="p14">
             <p:contentPart p14:bwMode="auto" r:id="rId44">
               <p14:nvContentPartPr>
                 <p14:cNvPr id="43" name="Ink 42">
@@ -18601,7 +19425,7 @@
               </p14:xfrm>
             </p:contentPart>
           </mc:Choice>
-          <mc:Fallback>
+          <mc:Fallback xmlns="">
             <p:pic>
               <p:nvPicPr>
                 <p:cNvPr id="43" name="Ink 42">
@@ -18632,8 +19456,8 @@
             </p:pic>
           </mc:Fallback>
         </mc:AlternateContent>
-        <mc:AlternateContent xmlns:mc="http://schemas.openxmlformats.org/markup-compatibility/2006">
-          <mc:Choice xmlns:p14="http://schemas.microsoft.com/office/powerpoint/2010/main" Requires="p14">
+        <mc:AlternateContent xmlns:mc="http://schemas.openxmlformats.org/markup-compatibility/2006" xmlns:p14="http://schemas.microsoft.com/office/powerpoint/2010/main">
+          <mc:Choice Requires="p14">
             <p:contentPart p14:bwMode="auto" r:id="rId46">
               <p14:nvContentPartPr>
                 <p14:cNvPr id="44" name="Ink 43">
@@ -18652,7 +19476,7 @@
               </p14:xfrm>
             </p:contentPart>
           </mc:Choice>
-          <mc:Fallback>
+          <mc:Fallback xmlns="">
             <p:pic>
               <p:nvPicPr>
                 <p:cNvPr id="44" name="Ink 43">

</xml_diff>

<commit_message>
Updated Outline of the class
Signed-off-by: JasonMendoza2008 <lhotteromain@gmail.com>
</commit_message>
<xml_diff>
--- a/Slides/Slides_3.pptx
+++ b/Slides/Slides_3.pptx
@@ -10247,7 +10247,7 @@
         </p:spPr>
         <p:txBody>
           <a:bodyPr>
-            <a:normAutofit lnSpcReduction="10000"/>
+            <a:normAutofit fontScale="92500"/>
           </a:bodyPr>
           <a:lstStyle/>
           <a:p>
@@ -10257,7 +10257,7 @@
             </a:pPr>
             <a:r>
               <a:rPr lang="fr-FR" sz="2400" dirty="0"/>
-              <a:t>Introduction to Deep Learning</a:t>
+              <a:t>Introduction to Deep Learning.</a:t>
             </a:r>
           </a:p>
           <a:p>
@@ -10266,8 +10266,12 @@
               <a:buAutoNum type="arabicPeriod"/>
             </a:pPr>
             <a:r>
+              <a:rPr lang="fr-FR" sz="2400" dirty="0" err="1"/>
+              <a:t>PyTorch</a:t>
+            </a:r>
+            <a:r>
               <a:rPr lang="fr-FR" sz="2400" dirty="0"/>
-              <a:t>PyTorch</a:t>
+              <a:t>.</a:t>
             </a:r>
           </a:p>
           <a:p>
@@ -10287,7 +10291,7 @@
             </a:pPr>
             <a:r>
               <a:rPr lang="en-US" sz="2400" dirty="0"/>
-              <a:t>Layers Types 1 (linear: width vs depth)</a:t>
+              <a:t>Layers Types 1 (linear: width vs depth).</a:t>
             </a:r>
           </a:p>
           <a:p>
@@ -10297,15 +10301,7 @@
             </a:pPr>
             <a:r>
               <a:rPr lang="en-US" sz="2400" dirty="0"/>
-              <a:t>Layers Types 2 (conv, pooling &amp; </a:t>
-            </a:r>
-            <a:r>
-              <a:rPr lang="en-US" sz="2400" dirty="0" err="1"/>
-              <a:t>softmax</a:t>
-            </a:r>
-            <a:r>
-              <a:rPr lang="en-US" sz="2400" dirty="0"/>
-              <a:t>)</a:t>
+              <a:t>Layers Types 2 (conv, pooling). Miscellaneous stuff.</a:t>
             </a:r>
           </a:p>
           <a:p>
@@ -10315,7 +10311,7 @@
             </a:pPr>
             <a:r>
               <a:rPr lang="en-US" sz="2400" dirty="0"/>
-              <a:t>Architectures (RNN) &amp; Transfer Learning</a:t>
+              <a:t>Architectures (RNN) &amp; Transfer Learning.</a:t>
             </a:r>
           </a:p>
           <a:p>
@@ -10325,7 +10321,7 @@
             </a:pPr>
             <a:r>
               <a:rPr lang="en-US" sz="2400" dirty="0"/>
-              <a:t>Practical Exercises and hyperparameter optimization</a:t>
+              <a:t>Practical Exercises.</a:t>
             </a:r>
           </a:p>
           <a:p>
@@ -10345,11 +10341,11 @@
             </a:pPr>
             <a:r>
               <a:rPr lang="en-US" sz="2400" dirty="0"/>
-              <a:t>Text Generation. </a:t>
+              <a:t>Stable Diffusion. Text Generation. </a:t>
             </a:r>
             <a:r>
               <a:rPr lang="en-GB" sz="2400" dirty="0"/>
-              <a:t>Low-Rank Adaptation of Large Language Models</a:t>
+              <a:t>Low-Rank Adaptation of Large Language Models.</a:t>
             </a:r>
             <a:endParaRPr lang="en-US" sz="2400" dirty="0"/>
           </a:p>
@@ -10360,7 +10356,7 @@
             </a:pPr>
             <a:r>
               <a:rPr lang="en-US" sz="2400" dirty="0"/>
-              <a:t>Exam</a:t>
+              <a:t>Exam.</a:t>
             </a:r>
           </a:p>
         </p:txBody>

</xml_diff>